<commit_message>
Deck allineato al run di riferimento 20260917_161535 (parte A: testi e numeri)
- Slide 2/10/11/12/13/14/18: 57x (era 89x), 671/12 ms, categoria A parita',
  Q09 2.1x, Q07 1.9x, Q12 4.5x fino al commit, 21->5 LOC, 26->5 operatori,
  11/12 significativi con Holm, PostgreSQL 18.6
- Slide 10: barre ridisegnate per direzione e log(speedup) del run nuovo
- Slide 12: SQL mostrato = quello eseguito (BFS su mv_played_for), Cypher =
  quantified path pattern con SHORTEST 1 e vincolo di stagione
- Slide 8: multiset, MV su Q09-Q10; slide 15: link al repo
- Speaker notes aggiornate

La parte visiva (grafici, ER, QR) resta per il passaggio con Claude design.

Co-Authored-By: Claude Opus 5 <noreply@anthropic.com>
</commit_message>
<xml_diff>
--- a/PostgreSQL_vs_Neo4j_DAngelica_Leone.pptx
+++ b/PostgreSQL_vs_Neo4j_DAngelica_Leone.pptx
@@ -694,10 +694,8 @@
           <a:lstStyle/>
           <a:p>
             <a:r>
-              <a:rPr lang="en-US" dirty="0"/>
-              <a:t>45 sec. Pausa a effetto. Non è tuning: il recursive CTE esplora tutto il fan-out, shortestPath si ferma appena tocca. Complessità diversa, non costante diversa.</a:t>
-            </a:r>
-            <a:endParaRPr lang="en-US" dirty="0"/>
+              <a:t>45 sec. Pausa a effetto. Non è tuning: il recursive CTE esplora tutto il fan-out, SHORTEST 1 si ferma appena tocca. Complessità diversa, non costante diversa.</a:t>
+            </a:r>
           </a:p>
         </p:txBody>
       </p:sp>
@@ -782,10 +780,8 @@
           <a:lstStyle/>
           <a:p>
             <a:r>
-              <a:rPr lang="en-US" dirty="0"/>
-              <a:t>60 sec. La sproporzione visiva È il messaggio: stessa domanda, 21 righe contro 3. Non leggere il codice: indicare solo la CTE ricorsiva a sinistra e shortestPath a destra.</a:t>
-            </a:r>
-            <a:endParaRPr lang="en-US" dirty="0"/>
+              <a:t>60 sec. La sproporzione visiva È il messaggio: stessa domanda, 21 righe contro 5. Non leggere il codice: indicare solo la CTE ricorsiva a sinistra e SHORTEST 1 a destra.</a:t>
+            </a:r>
           </a:p>
         </p:txBody>
       </p:sp>
@@ -870,10 +866,8 @@
           <a:lstStyle/>
           <a:p>
             <a:r>
-              <a:rPr lang="en-US" dirty="0"/>
-              <a:t>60 sec. Due dimensioni non-performance: concisione del codice e agilità dello schema. Q12: ALTER + UPDATE + lock contro un singolo SET — 13.7 volte più veloce, ma il punto vero è il change-management.</a:t>
-            </a:r>
-            <a:endParaRPr lang="en-US" dirty="0"/>
+              <a:t>60 sec. Due dimensioni non-performance: concisione del codice e agilità dello schema. Q12: ALTER + UPDATE + lock contro un singolo SET — 4.5 volte più veloce, ma il punto vero è il change-management.</a:t>
+            </a:r>
           </a:p>
         </p:txBody>
       </p:sp>
@@ -2813,7 +2807,7 @@
                 <a:ea typeface="Space Grotesk" pitchFamily="34" charset="-122"/>
                 <a:cs typeface="Space Grotesk" pitchFamily="34" charset="-120"/>
               </a:rPr>
-              <a:t>The pattern is clean: Postgres wins all of category A, Neo4j takes 7 of the remaining 8</a:t>
+              <a:t>Category A (&lt; 15 ms) is a dead heat; Postgres wins the fixed-depth join (Q09), Neo4j wins every variable-depth traversal and every write</a:t>
             </a:r>
             <a:endParaRPr lang="en-US" sz="4350" dirty="0"/>
           </a:p>
@@ -3113,8 +3107,334 @@
         </p:nvSpPr>
         <p:spPr>
           <a:xfrm>
-            <a:off x="7250079" y="3257536"/>
-            <a:ext cx="161810" cy="285715"/>
+            <a:off x="7424927" y="3257536"/>
+            <a:ext cx="360397" cy="285715"/>
+          </a:xfrm>
+          <a:prstGeom prst="rect">
+            <a:avLst/>
+          </a:prstGeom>
+          <a:solidFill>
+            <a:srgbClr val="1E7A52"/>
+          </a:solidFill>
+          <a:ln/>
+        </p:spPr>
+      </p:sp>
+      <p:sp>
+        <p:nvSpPr>
+          <p:cNvPr id="13" name="Text 11"/>
+          <p:cNvSpPr/>
+          <p:nvPr/>
+        </p:nvSpPr>
+        <p:spPr>
+          <a:xfrm>
+            <a:off x="10860144" y="3181454"/>
+            <a:ext cx="6475430" cy="476115"/>
+          </a:xfrm>
+          <a:prstGeom prst="rect">
+            <a:avLst/>
+          </a:prstGeom>
+          <a:noFill/>
+          <a:ln/>
+        </p:spPr>
+        <p:txBody>
+          <a:bodyPr wrap="square" lIns="25400" tIns="25400" rIns="25400" bIns="25400" rtlCol="0" anchor="ctr">
+            <a:normAutofit/>
+          </a:bodyPr>
+          <a:lstStyle/>
+          <a:p>
+            <a:pPr algn="r" indent="0" marL="0">
+              <a:buNone/>
+            </a:pPr>
+            <a:r>
+              <a:rPr lang="en-US" sz="1725" b="1" dirty="0">
+                <a:solidFill>
+                  <a:srgbClr val="33608F"/>
+                </a:solidFill>
+                <a:latin typeface="IBM Plex Mono" pitchFamily="34" charset="0"/>
+                <a:ea typeface="IBM Plex Mono" pitchFamily="34" charset="-122"/>
+                <a:cs typeface="IBM Plex Mono" pitchFamily="34" charset="-120"/>
+              </a:rPr>
+              <a:t>1.58×*</a:t>
+            </a:r>
+            <a:endParaRPr lang="en-US" sz="1725" dirty="0"/>
+          </a:p>
+        </p:txBody>
+      </p:sp>
+      <p:sp>
+        <p:nvSpPr>
+          <p:cNvPr id="14" name="Text 12"/>
+          <p:cNvSpPr/>
+          <p:nvPr/>
+        </p:nvSpPr>
+        <p:spPr>
+          <a:xfrm>
+            <a:off x="952385" y="3619469"/>
+            <a:ext cx="628610" cy="325038"/>
+          </a:xfrm>
+          <a:prstGeom prst="rect">
+            <a:avLst/>
+          </a:prstGeom>
+          <a:noFill/>
+          <a:ln/>
+        </p:spPr>
+        <p:txBody>
+          <a:bodyPr wrap="square" lIns="25400" tIns="25400" rIns="25400" bIns="25400" rtlCol="0" anchor="t">
+            <a:normAutofit/>
+          </a:bodyPr>
+          <a:lstStyle/>
+          <a:p>
+            <a:pPr algn="l" indent="0" marL="0">
+              <a:buNone/>
+            </a:pPr>
+            <a:r>
+              <a:rPr lang="en-US" sz="1725" b="1" dirty="0">
+                <a:solidFill>
+                  <a:srgbClr val="1A2430"/>
+                </a:solidFill>
+                <a:latin typeface="IBM Plex Mono" pitchFamily="34" charset="0"/>
+                <a:ea typeface="IBM Plex Mono" pitchFamily="34" charset="-122"/>
+                <a:cs typeface="IBM Plex Mono" pitchFamily="34" charset="-120"/>
+              </a:rPr>
+              <a:t>Q02</a:t>
+            </a:r>
+            <a:endParaRPr lang="en-US" sz="1725" dirty="0"/>
+          </a:p>
+        </p:txBody>
+      </p:sp>
+      <p:sp>
+        <p:nvSpPr>
+          <p:cNvPr id="15" name="Text 13"/>
+          <p:cNvSpPr/>
+          <p:nvPr/>
+        </p:nvSpPr>
+        <p:spPr>
+          <a:xfrm>
+            <a:off x="1638074" y="3636859"/>
+            <a:ext cx="1988691" cy="307648"/>
+          </a:xfrm>
+          <a:prstGeom prst="rect">
+            <a:avLst/>
+          </a:prstGeom>
+          <a:noFill/>
+          <a:ln/>
+        </p:spPr>
+        <p:txBody>
+          <a:bodyPr wrap="square" lIns="25400" tIns="25400" rIns="25400" bIns="25400" rtlCol="0" anchor="t">
+            <a:normAutofit/>
+          </a:bodyPr>
+          <a:lstStyle/>
+          <a:p>
+            <a:pPr algn="l" indent="0" marL="0">
+              <a:buNone/>
+            </a:pPr>
+            <a:r>
+              <a:rPr lang="en-US" sz="1650" dirty="0">
+                <a:solidFill>
+                  <a:srgbClr val="6B655C"/>
+                </a:solidFill>
+                <a:latin typeface="Space Grotesk" pitchFamily="34" charset="0"/>
+                <a:ea typeface="Space Grotesk" pitchFamily="34" charset="-122"/>
+                <a:cs typeface="Space Grotesk" pitchFamily="34" charset="-120"/>
+              </a:rPr>
+              <a:t>League standings</a:t>
+            </a:r>
+            <a:endParaRPr lang="en-US" sz="1650" dirty="0"/>
+          </a:p>
+        </p:txBody>
+      </p:sp>
+      <p:sp>
+        <p:nvSpPr>
+          <p:cNvPr id="16" name="Shape 14"/>
+          <p:cNvSpPr/>
+          <p:nvPr/>
+        </p:nvSpPr>
+        <p:spPr>
+          <a:xfrm>
+            <a:off x="7411889" y="3619469"/>
+            <a:ext cx="17390" cy="438015"/>
+          </a:xfrm>
+          <a:prstGeom prst="rect">
+            <a:avLst/>
+          </a:prstGeom>
+          <a:solidFill>
+            <a:srgbClr val="1A2430"/>
+          </a:solidFill>
+          <a:ln/>
+        </p:spPr>
+      </p:sp>
+      <p:sp>
+        <p:nvSpPr>
+          <p:cNvPr id="17" name="Shape 15"/>
+          <p:cNvSpPr/>
+          <p:nvPr/>
+        </p:nvSpPr>
+        <p:spPr>
+          <a:xfrm>
+            <a:off x="7424927" y="3695551"/>
+            <a:ext cx="169482" cy="285715"/>
+          </a:xfrm>
+          <a:prstGeom prst="rect">
+            <a:avLst/>
+          </a:prstGeom>
+          <a:solidFill>
+            <a:srgbClr val="1E7A52"/>
+          </a:solidFill>
+          <a:ln/>
+        </p:spPr>
+      </p:sp>
+      <p:sp>
+        <p:nvSpPr>
+          <p:cNvPr id="18" name="Text 16"/>
+          <p:cNvSpPr/>
+          <p:nvPr/>
+        </p:nvSpPr>
+        <p:spPr>
+          <a:xfrm>
+            <a:off x="10860144" y="3619469"/>
+            <a:ext cx="6475430" cy="476115"/>
+          </a:xfrm>
+          <a:prstGeom prst="rect">
+            <a:avLst/>
+          </a:prstGeom>
+          <a:noFill/>
+          <a:ln/>
+        </p:spPr>
+        <p:txBody>
+          <a:bodyPr wrap="square" lIns="25400" tIns="25400" rIns="25400" bIns="25400" rtlCol="0" anchor="ctr">
+            <a:normAutofit/>
+          </a:bodyPr>
+          <a:lstStyle/>
+          <a:p>
+            <a:pPr algn="r" indent="0" marL="0">
+              <a:buNone/>
+            </a:pPr>
+            <a:r>
+              <a:rPr lang="en-US" sz="1725" b="1" dirty="0">
+                <a:solidFill>
+                  <a:srgbClr val="33608F"/>
+                </a:solidFill>
+                <a:latin typeface="IBM Plex Mono" pitchFamily="34" charset="0"/>
+                <a:ea typeface="IBM Plex Mono" pitchFamily="34" charset="-122"/>
+                <a:cs typeface="IBM Plex Mono" pitchFamily="34" charset="-120"/>
+              </a:rPr>
+              <a:t>1.24×*</a:t>
+            </a:r>
+            <a:endParaRPr lang="en-US" sz="1725" dirty="0"/>
+          </a:p>
+        </p:txBody>
+      </p:sp>
+      <p:sp>
+        <p:nvSpPr>
+          <p:cNvPr id="19" name="Text 17"/>
+          <p:cNvSpPr/>
+          <p:nvPr/>
+        </p:nvSpPr>
+        <p:spPr>
+          <a:xfrm>
+            <a:off x="952385" y="4057485"/>
+            <a:ext cx="628610" cy="325038"/>
+          </a:xfrm>
+          <a:prstGeom prst="rect">
+            <a:avLst/>
+          </a:prstGeom>
+          <a:noFill/>
+          <a:ln/>
+        </p:spPr>
+        <p:txBody>
+          <a:bodyPr wrap="square" lIns="25400" tIns="25400" rIns="25400" bIns="25400" rtlCol="0" anchor="t">
+            <a:normAutofit/>
+          </a:bodyPr>
+          <a:lstStyle/>
+          <a:p>
+            <a:pPr algn="l" indent="0" marL="0">
+              <a:buNone/>
+            </a:pPr>
+            <a:r>
+              <a:rPr lang="en-US" sz="1725" b="1" dirty="0">
+                <a:solidFill>
+                  <a:srgbClr val="1A2430"/>
+                </a:solidFill>
+                <a:latin typeface="IBM Plex Mono" pitchFamily="34" charset="0"/>
+                <a:ea typeface="IBM Plex Mono" pitchFamily="34" charset="-122"/>
+                <a:cs typeface="IBM Plex Mono" pitchFamily="34" charset="-120"/>
+              </a:rPr>
+              <a:t>Q03</a:t>
+            </a:r>
+            <a:endParaRPr lang="en-US" sz="1725" dirty="0"/>
+          </a:p>
+        </p:txBody>
+      </p:sp>
+      <p:sp>
+        <p:nvSpPr>
+          <p:cNvPr id="20" name="Text 18"/>
+          <p:cNvSpPr/>
+          <p:nvPr/>
+        </p:nvSpPr>
+        <p:spPr>
+          <a:xfrm>
+            <a:off x="1638074" y="4074875"/>
+            <a:ext cx="1798893" cy="307648"/>
+          </a:xfrm>
+          <a:prstGeom prst="rect">
+            <a:avLst/>
+          </a:prstGeom>
+          <a:noFill/>
+          <a:ln/>
+        </p:spPr>
+        <p:txBody>
+          <a:bodyPr wrap="square" lIns="25400" tIns="25400" rIns="25400" bIns="25400" rtlCol="0" anchor="t">
+            <a:normAutofit/>
+          </a:bodyPr>
+          <a:lstStyle/>
+          <a:p>
+            <a:pPr algn="l" indent="0" marL="0">
+              <a:buNone/>
+            </a:pPr>
+            <a:r>
+              <a:rPr lang="en-US" sz="1650" dirty="0">
+                <a:solidFill>
+                  <a:srgbClr val="6B655C"/>
+                </a:solidFill>
+                <a:latin typeface="Space Grotesk" pitchFamily="34" charset="0"/>
+                <a:ea typeface="Space Grotesk" pitchFamily="34" charset="-122"/>
+                <a:cs typeface="Space Grotesk" pitchFamily="34" charset="-120"/>
+              </a:rPr>
+              <a:t>Goals per match</a:t>
+            </a:r>
+            <a:endParaRPr lang="en-US" sz="1650" dirty="0"/>
+          </a:p>
+        </p:txBody>
+      </p:sp>
+      <p:sp>
+        <p:nvSpPr>
+          <p:cNvPr id="21" name="Shape 19"/>
+          <p:cNvSpPr/>
+          <p:nvPr/>
+        </p:nvSpPr>
+        <p:spPr>
+          <a:xfrm>
+            <a:off x="7411889" y="4057485"/>
+            <a:ext cx="17390" cy="438015"/>
+          </a:xfrm>
+          <a:prstGeom prst="rect">
+            <a:avLst/>
+          </a:prstGeom>
+          <a:solidFill>
+            <a:srgbClr val="1A2430"/>
+          </a:solidFill>
+          <a:ln/>
+        </p:spPr>
+      </p:sp>
+      <p:sp>
+        <p:nvSpPr>
+          <p:cNvPr id="22" name="Shape 20"/>
+          <p:cNvSpPr/>
+          <p:nvPr/>
+        </p:nvSpPr>
+        <p:spPr>
+          <a:xfrm>
+            <a:off x="7306055" y="4133567"/>
+            <a:ext cx="109728" cy="285715"/>
           </a:xfrm>
           <a:prstGeom prst="rect">
             <a:avLst/>
@@ -3127,13 +3447,13 @@
       </p:sp>
       <p:sp>
         <p:nvSpPr>
-          <p:cNvPr id="13" name="Text 11"/>
-          <p:cNvSpPr/>
-          <p:nvPr/>
-        </p:nvSpPr>
-        <p:spPr>
-          <a:xfrm>
-            <a:off x="10860144" y="3181454"/>
+          <p:cNvPr id="23" name="Text 21"/>
+          <p:cNvSpPr/>
+          <p:nvPr/>
+        </p:nvSpPr>
+        <p:spPr>
+          <a:xfrm>
+            <a:off x="10860144" y="4057485"/>
             <a:ext cx="6475430" cy="476115"/>
           </a:xfrm>
           <a:prstGeom prst="rect">
@@ -3160,7 +3480,7 @@
                 <a:ea typeface="IBM Plex Mono" pitchFamily="34" charset="-122"/>
                 <a:cs typeface="IBM Plex Mono" pitchFamily="34" charset="-120"/>
               </a:rPr>
-              <a:t>1.23×</a:t>
+              <a:t>1.03×</a:t>
             </a:r>
             <a:endParaRPr lang="en-US" sz="1725" dirty="0"/>
           </a:p>
@@ -3168,13 +3488,13 @@
       </p:sp>
       <p:sp>
         <p:nvSpPr>
-          <p:cNvPr id="14" name="Text 12"/>
-          <p:cNvSpPr/>
-          <p:nvPr/>
-        </p:nvSpPr>
-        <p:spPr>
-          <a:xfrm>
-            <a:off x="952385" y="3619469"/>
+          <p:cNvPr id="24" name="Text 22"/>
+          <p:cNvSpPr/>
+          <p:nvPr/>
+        </p:nvSpPr>
+        <p:spPr>
+          <a:xfrm>
+            <a:off x="952385" y="4495500"/>
             <a:ext cx="628610" cy="325038"/>
           </a:xfrm>
           <a:prstGeom prst="rect">
@@ -3201,7 +3521,7 @@
                 <a:ea typeface="IBM Plex Mono" pitchFamily="34" charset="-122"/>
                 <a:cs typeface="IBM Plex Mono" pitchFamily="34" charset="-120"/>
               </a:rPr>
-              <a:t>Q02</a:t>
+              <a:t>Q04</a:t>
             </a:r>
             <a:endParaRPr lang="en-US" sz="1725" dirty="0"/>
           </a:p>
@@ -3209,14 +3529,14 @@
       </p:sp>
       <p:sp>
         <p:nvSpPr>
-          <p:cNvPr id="15" name="Text 13"/>
-          <p:cNvSpPr/>
-          <p:nvPr/>
-        </p:nvSpPr>
-        <p:spPr>
-          <a:xfrm>
-            <a:off x="1638074" y="3636859"/>
-            <a:ext cx="1988691" cy="307648"/>
+          <p:cNvPr id="25" name="Text 23"/>
+          <p:cNvSpPr/>
+          <p:nvPr/>
+        </p:nvSpPr>
+        <p:spPr>
+          <a:xfrm>
+            <a:off x="1638074" y="4512890"/>
+            <a:ext cx="2283251" cy="307648"/>
           </a:xfrm>
           <a:prstGeom prst="rect">
             <a:avLst/>
@@ -3242,7 +3562,7 @@
                 <a:ea typeface="Space Grotesk" pitchFamily="34" charset="-122"/>
                 <a:cs typeface="Space Grotesk" pitchFamily="34" charset="-120"/>
               </a:rPr>
-              <a:t>League standings</a:t>
+              <a:t>Home win % by team</a:t>
             </a:r>
             <a:endParaRPr lang="en-US" sz="1650" dirty="0"/>
           </a:p>
@@ -3250,13 +3570,13 @@
       </p:sp>
       <p:sp>
         <p:nvSpPr>
-          <p:cNvPr id="16" name="Shape 14"/>
-          <p:cNvSpPr/>
-          <p:nvPr/>
-        </p:nvSpPr>
-        <p:spPr>
-          <a:xfrm>
-            <a:off x="7411889" y="3619469"/>
+          <p:cNvPr id="26" name="Shape 24"/>
+          <p:cNvSpPr/>
+          <p:nvPr/>
+        </p:nvSpPr>
+        <p:spPr>
+          <a:xfrm>
+            <a:off x="7411889" y="4495500"/>
             <a:ext cx="17390" cy="438015"/>
           </a:xfrm>
           <a:prstGeom prst="rect">
@@ -3270,14 +3590,14 @@
       </p:sp>
       <p:sp>
         <p:nvSpPr>
-          <p:cNvPr id="17" name="Shape 15"/>
-          <p:cNvSpPr/>
-          <p:nvPr/>
-        </p:nvSpPr>
-        <p:spPr>
-          <a:xfrm>
-            <a:off x="7278610" y="3695551"/>
-            <a:ext cx="133280" cy="285715"/>
+          <p:cNvPr id="27" name="Shape 25"/>
+          <p:cNvSpPr/>
+          <p:nvPr/>
+        </p:nvSpPr>
+        <p:spPr>
+          <a:xfrm>
+            <a:off x="7272135" y="4571582"/>
+            <a:ext cx="143648" cy="285715"/>
           </a:xfrm>
           <a:prstGeom prst="rect">
             <a:avLst/>
@@ -3290,13 +3610,13 @@
       </p:sp>
       <p:sp>
         <p:nvSpPr>
-          <p:cNvPr id="18" name="Text 16"/>
-          <p:cNvSpPr/>
-          <p:nvPr/>
-        </p:nvSpPr>
-        <p:spPr>
-          <a:xfrm>
-            <a:off x="10860144" y="3619469"/>
+          <p:cNvPr id="28" name="Text 26"/>
+          <p:cNvSpPr/>
+          <p:nvPr/>
+        </p:nvSpPr>
+        <p:spPr>
+          <a:xfrm>
+            <a:off x="10860144" y="4495500"/>
             <a:ext cx="6475430" cy="476115"/>
           </a:xfrm>
           <a:prstGeom prst="rect">
@@ -3323,7 +3643,7 @@
                 <a:ea typeface="IBM Plex Mono" pitchFamily="34" charset="-122"/>
                 <a:cs typeface="IBM Plex Mono" pitchFamily="34" charset="-120"/>
               </a:rPr>
-              <a:t>1.19×*</a:t>
+              <a:t>1.20×*</a:t>
             </a:r>
             <a:endParaRPr lang="en-US" sz="1725" dirty="0"/>
           </a:p>
@@ -3331,13 +3651,13 @@
       </p:sp>
       <p:sp>
         <p:nvSpPr>
-          <p:cNvPr id="19" name="Text 17"/>
-          <p:cNvSpPr/>
-          <p:nvPr/>
-        </p:nvSpPr>
-        <p:spPr>
-          <a:xfrm>
-            <a:off x="952385" y="4057485"/>
+          <p:cNvPr id="29" name="Text 27"/>
+          <p:cNvSpPr/>
+          <p:nvPr/>
+        </p:nvSpPr>
+        <p:spPr>
+          <a:xfrm>
+            <a:off x="952385" y="4933516"/>
             <a:ext cx="628610" cy="325038"/>
           </a:xfrm>
           <a:prstGeom prst="rect">
@@ -3364,7 +3684,7 @@
                 <a:ea typeface="IBM Plex Mono" pitchFamily="34" charset="-122"/>
                 <a:cs typeface="IBM Plex Mono" pitchFamily="34" charset="-120"/>
               </a:rPr>
-              <a:t>Q03</a:t>
+              <a:t>Q05</a:t>
             </a:r>
             <a:endParaRPr lang="en-US" sz="1725" dirty="0"/>
           </a:p>
@@ -3372,14 +3692,14 @@
       </p:sp>
       <p:sp>
         <p:nvSpPr>
-          <p:cNvPr id="20" name="Text 18"/>
-          <p:cNvSpPr/>
-          <p:nvPr/>
-        </p:nvSpPr>
-        <p:spPr>
-          <a:xfrm>
-            <a:off x="1638074" y="4074875"/>
-            <a:ext cx="1798893" cy="307648"/>
+          <p:cNvPr id="30" name="Text 28"/>
+          <p:cNvSpPr/>
+          <p:nvPr/>
+        </p:nvSpPr>
+        <p:spPr>
+          <a:xfrm>
+            <a:off x="1638074" y="4950906"/>
+            <a:ext cx="2304920" cy="307648"/>
           </a:xfrm>
           <a:prstGeom prst="rect">
             <a:avLst/>
@@ -3405,7 +3725,7 @@
                 <a:ea typeface="Space Grotesk" pitchFamily="34" charset="-122"/>
                 <a:cs typeface="Space Grotesk" pitchFamily="34" charset="-120"/>
               </a:rPr>
-              <a:t>Goals per match</a:t>
+              <a:t>Goal-assist partnerships</a:t>
             </a:r>
             <a:endParaRPr lang="en-US" sz="1650" dirty="0"/>
           </a:p>
@@ -3413,13 +3733,13 @@
       </p:sp>
       <p:sp>
         <p:nvSpPr>
-          <p:cNvPr id="21" name="Shape 19"/>
-          <p:cNvSpPr/>
-          <p:nvPr/>
-        </p:nvSpPr>
-        <p:spPr>
-          <a:xfrm>
-            <a:off x="7411889" y="4057485"/>
+          <p:cNvPr id="31" name="Shape 29"/>
+          <p:cNvSpPr/>
+          <p:nvPr/>
+        </p:nvSpPr>
+        <p:spPr>
+          <a:xfrm>
+            <a:off x="7411889" y="4933516"/>
             <a:ext cx="17390" cy="438015"/>
           </a:xfrm>
           <a:prstGeom prst="rect">
@@ -3433,14 +3753,666 @@
       </p:sp>
       <p:sp>
         <p:nvSpPr>
-          <p:cNvPr id="22" name="Shape 20"/>
-          <p:cNvSpPr/>
-          <p:nvPr/>
-        </p:nvSpPr>
-        <p:spPr>
-          <a:xfrm>
-            <a:off x="6821438" y="4133567"/>
-            <a:ext cx="590451" cy="285715"/>
+          <p:cNvPr id="32" name="Shape 30"/>
+          <p:cNvSpPr/>
+          <p:nvPr/>
+        </p:nvSpPr>
+        <p:spPr>
+          <a:xfrm>
+            <a:off x="7424927" y="5009598"/>
+            <a:ext cx="200628" cy="285715"/>
+          </a:xfrm>
+          <a:prstGeom prst="rect">
+            <a:avLst/>
+          </a:prstGeom>
+          <a:solidFill>
+            <a:srgbClr val="1E7A52"/>
+          </a:solidFill>
+          <a:ln/>
+        </p:spPr>
+      </p:sp>
+      <p:sp>
+        <p:nvSpPr>
+          <p:cNvPr id="33" name="Text 31"/>
+          <p:cNvSpPr/>
+          <p:nvPr/>
+        </p:nvSpPr>
+        <p:spPr>
+          <a:xfrm>
+            <a:off x="10860144" y="4933516"/>
+            <a:ext cx="6475430" cy="476115"/>
+          </a:xfrm>
+          <a:prstGeom prst="rect">
+            <a:avLst/>
+          </a:prstGeom>
+          <a:noFill/>
+          <a:ln/>
+        </p:spPr>
+        <p:txBody>
+          <a:bodyPr wrap="square" lIns="25400" tIns="25400" rIns="25400" bIns="25400" rtlCol="0" anchor="ctr">
+            <a:normAutofit/>
+          </a:bodyPr>
+          <a:lstStyle/>
+          <a:p>
+            <a:pPr algn="r" indent="0" marL="0">
+              <a:buNone/>
+            </a:pPr>
+            <a:r>
+              <a:rPr lang="en-US" sz="1725" b="1" dirty="0">
+                <a:solidFill>
+                  <a:srgbClr val="1E7A52"/>
+                </a:solidFill>
+                <a:latin typeface="IBM Plex Mono" pitchFamily="34" charset="0"/>
+                <a:ea typeface="IBM Plex Mono" pitchFamily="34" charset="-122"/>
+                <a:cs typeface="IBM Plex Mono" pitchFamily="34" charset="-120"/>
+              </a:rPr>
+              <a:t>1.29×*</a:t>
+            </a:r>
+            <a:endParaRPr lang="en-US" sz="1725" dirty="0"/>
+          </a:p>
+        </p:txBody>
+      </p:sp>
+      <p:sp>
+        <p:nvSpPr>
+          <p:cNvPr id="34" name="Text 32"/>
+          <p:cNvSpPr/>
+          <p:nvPr/>
+        </p:nvSpPr>
+        <p:spPr>
+          <a:xfrm>
+            <a:off x="952385" y="5371531"/>
+            <a:ext cx="628610" cy="325038"/>
+          </a:xfrm>
+          <a:prstGeom prst="rect">
+            <a:avLst/>
+          </a:prstGeom>
+          <a:noFill/>
+          <a:ln/>
+        </p:spPr>
+        <p:txBody>
+          <a:bodyPr wrap="square" lIns="25400" tIns="25400" rIns="25400" bIns="25400" rtlCol="0" anchor="t">
+            <a:normAutofit/>
+          </a:bodyPr>
+          <a:lstStyle/>
+          <a:p>
+            <a:pPr algn="l" indent="0" marL="0">
+              <a:buNone/>
+            </a:pPr>
+            <a:r>
+              <a:rPr lang="en-US" sz="1725" b="1" dirty="0">
+                <a:solidFill>
+                  <a:srgbClr val="1A2430"/>
+                </a:solidFill>
+                <a:latin typeface="IBM Plex Mono" pitchFamily="34" charset="0"/>
+                <a:ea typeface="IBM Plex Mono" pitchFamily="34" charset="-122"/>
+                <a:cs typeface="IBM Plex Mono" pitchFamily="34" charset="-120"/>
+              </a:rPr>
+              <a:t>Q06</a:t>
+            </a:r>
+            <a:endParaRPr lang="en-US" sz="1725" dirty="0"/>
+          </a:p>
+        </p:txBody>
+      </p:sp>
+      <p:sp>
+        <p:nvSpPr>
+          <p:cNvPr id="35" name="Text 33"/>
+          <p:cNvSpPr/>
+          <p:nvPr/>
+        </p:nvSpPr>
+        <p:spPr>
+          <a:xfrm>
+            <a:off x="1638074" y="5388921"/>
+            <a:ext cx="2291918" cy="307648"/>
+          </a:xfrm>
+          <a:prstGeom prst="rect">
+            <a:avLst/>
+          </a:prstGeom>
+          <a:noFill/>
+          <a:ln/>
+        </p:spPr>
+        <p:txBody>
+          <a:bodyPr wrap="square" lIns="25400" tIns="25400" rIns="25400" bIns="25400" rtlCol="0" anchor="t">
+            <a:normAutofit/>
+          </a:bodyPr>
+          <a:lstStyle/>
+          <a:p>
+            <a:pPr algn="l" indent="0" marL="0">
+              <a:buNone/>
+            </a:pPr>
+            <a:r>
+              <a:rPr lang="en-US" sz="1650" dirty="0">
+                <a:solidFill>
+                  <a:srgbClr val="6B655C"/>
+                </a:solidFill>
+                <a:latin typeface="Space Grotesk" pitchFamily="34" charset="0"/>
+                <a:ea typeface="Space Grotesk" pitchFamily="34" charset="-122"/>
+                <a:cs typeface="Space Grotesk" pitchFamily="34" charset="-120"/>
+              </a:rPr>
+              <a:t>Cards vs Real Madrid</a:t>
+            </a:r>
+            <a:endParaRPr lang="en-US" sz="1650" dirty="0"/>
+          </a:p>
+        </p:txBody>
+      </p:sp>
+      <p:sp>
+        <p:nvSpPr>
+          <p:cNvPr id="36" name="Shape 34"/>
+          <p:cNvSpPr/>
+          <p:nvPr/>
+        </p:nvSpPr>
+        <p:spPr>
+          <a:xfrm>
+            <a:off x="7411889" y="5371531"/>
+            <a:ext cx="17390" cy="438015"/>
+          </a:xfrm>
+          <a:prstGeom prst="rect">
+            <a:avLst/>
+          </a:prstGeom>
+          <a:solidFill>
+            <a:srgbClr val="1A2430"/>
+          </a:solidFill>
+          <a:ln/>
+        </p:spPr>
+      </p:sp>
+      <p:sp>
+        <p:nvSpPr>
+          <p:cNvPr id="37" name="Shape 35"/>
+          <p:cNvSpPr/>
+          <p:nvPr/>
+        </p:nvSpPr>
+        <p:spPr>
+          <a:xfrm>
+            <a:off x="7424927" y="5447613"/>
+            <a:ext cx="1017933" cy="285715"/>
+          </a:xfrm>
+          <a:prstGeom prst="rect">
+            <a:avLst/>
+          </a:prstGeom>
+          <a:solidFill>
+            <a:srgbClr val="1E7A52"/>
+          </a:solidFill>
+          <a:ln/>
+        </p:spPr>
+      </p:sp>
+      <p:sp>
+        <p:nvSpPr>
+          <p:cNvPr id="38" name="Text 36"/>
+          <p:cNvSpPr/>
+          <p:nvPr/>
+        </p:nvSpPr>
+        <p:spPr>
+          <a:xfrm>
+            <a:off x="10860144" y="5371531"/>
+            <a:ext cx="6475430" cy="476115"/>
+          </a:xfrm>
+          <a:prstGeom prst="rect">
+            <a:avLst/>
+          </a:prstGeom>
+          <a:noFill/>
+          <a:ln/>
+        </p:spPr>
+        <p:txBody>
+          <a:bodyPr wrap="square" lIns="25400" tIns="25400" rIns="25400" bIns="25400" rtlCol="0" anchor="ctr">
+            <a:normAutofit/>
+          </a:bodyPr>
+          <a:lstStyle/>
+          <a:p>
+            <a:pPr algn="r" indent="0" marL="0">
+              <a:buNone/>
+            </a:pPr>
+            <a:r>
+              <a:rPr lang="en-US" sz="1725" b="1" dirty="0">
+                <a:solidFill>
+                  <a:srgbClr val="1E7A52"/>
+                </a:solidFill>
+                <a:latin typeface="IBM Plex Mono" pitchFamily="34" charset="0"/>
+                <a:ea typeface="IBM Plex Mono" pitchFamily="34" charset="-122"/>
+                <a:cs typeface="IBM Plex Mono" pitchFamily="34" charset="-120"/>
+              </a:rPr>
+              <a:t>3.64×*</a:t>
+            </a:r>
+            <a:endParaRPr lang="en-US" sz="1725" dirty="0"/>
+          </a:p>
+        </p:txBody>
+      </p:sp>
+      <p:sp>
+        <p:nvSpPr>
+          <p:cNvPr id="39" name="Text 37"/>
+          <p:cNvSpPr/>
+          <p:nvPr/>
+        </p:nvSpPr>
+        <p:spPr>
+          <a:xfrm>
+            <a:off x="952385" y="5809547"/>
+            <a:ext cx="628610" cy="325038"/>
+          </a:xfrm>
+          <a:prstGeom prst="rect">
+            <a:avLst/>
+          </a:prstGeom>
+          <a:noFill/>
+          <a:ln/>
+        </p:spPr>
+        <p:txBody>
+          <a:bodyPr wrap="square" lIns="25400" tIns="25400" rIns="25400" bIns="25400" rtlCol="0" anchor="t">
+            <a:normAutofit/>
+          </a:bodyPr>
+          <a:lstStyle/>
+          <a:p>
+            <a:pPr algn="l" indent="0" marL="0">
+              <a:buNone/>
+            </a:pPr>
+            <a:r>
+              <a:rPr lang="en-US" sz="1725" b="1" dirty="0">
+                <a:solidFill>
+                  <a:srgbClr val="1A2430"/>
+                </a:solidFill>
+                <a:latin typeface="IBM Plex Mono" pitchFamily="34" charset="0"/>
+                <a:ea typeface="IBM Plex Mono" pitchFamily="34" charset="-122"/>
+                <a:cs typeface="IBM Plex Mono" pitchFamily="34" charset="-120"/>
+              </a:rPr>
+              <a:t>Q07</a:t>
+            </a:r>
+            <a:endParaRPr lang="en-US" sz="1725" dirty="0"/>
+          </a:p>
+        </p:txBody>
+      </p:sp>
+      <p:sp>
+        <p:nvSpPr>
+          <p:cNvPr id="40" name="Text 38"/>
+          <p:cNvSpPr/>
+          <p:nvPr/>
+        </p:nvSpPr>
+        <p:spPr>
+          <a:xfrm>
+            <a:off x="1638074" y="5826937"/>
+            <a:ext cx="2304920" cy="307648"/>
+          </a:xfrm>
+          <a:prstGeom prst="rect">
+            <a:avLst/>
+          </a:prstGeom>
+          <a:noFill/>
+          <a:ln/>
+        </p:spPr>
+        <p:txBody>
+          <a:bodyPr wrap="square" lIns="25400" tIns="25400" rIns="25400" bIns="25400" rtlCol="0" anchor="t">
+            <a:normAutofit/>
+          </a:bodyPr>
+          <a:lstStyle/>
+          <a:p>
+            <a:pPr algn="l" indent="0" marL="0">
+              <a:buNone/>
+            </a:pPr>
+            <a:r>
+              <a:rPr lang="en-US" sz="1650" dirty="0">
+                <a:solidFill>
+                  <a:srgbClr val="6B655C"/>
+                </a:solidFill>
+                <a:latin typeface="Space Grotesk" pitchFamily="34" charset="0"/>
+                <a:ea typeface="Space Grotesk" pitchFamily="34" charset="-122"/>
+                <a:cs typeface="Space Grotesk" pitchFamily="34" charset="-120"/>
+              </a:rPr>
+              <a:t>Players in all 8 seasons</a:t>
+            </a:r>
+            <a:endParaRPr lang="en-US" sz="1650" dirty="0"/>
+          </a:p>
+        </p:txBody>
+      </p:sp>
+      <p:sp>
+        <p:nvSpPr>
+          <p:cNvPr id="41" name="Shape 39"/>
+          <p:cNvSpPr/>
+          <p:nvPr/>
+        </p:nvSpPr>
+        <p:spPr>
+          <a:xfrm>
+            <a:off x="7411889" y="5809547"/>
+            <a:ext cx="17390" cy="438015"/>
+          </a:xfrm>
+          <a:prstGeom prst="rect">
+            <a:avLst/>
+          </a:prstGeom>
+          <a:solidFill>
+            <a:srgbClr val="1A2430"/>
+          </a:solidFill>
+          <a:ln/>
+        </p:spPr>
+      </p:sp>
+      <p:sp>
+        <p:nvSpPr>
+          <p:cNvPr id="42" name="Shape 40"/>
+          <p:cNvSpPr/>
+          <p:nvPr/>
+        </p:nvSpPr>
+        <p:spPr>
+          <a:xfrm>
+            <a:off x="7424927" y="5885629"/>
+            <a:ext cx="509842" cy="285715"/>
+          </a:xfrm>
+          <a:prstGeom prst="rect">
+            <a:avLst/>
+          </a:prstGeom>
+          <a:solidFill>
+            <a:srgbClr val="1E7A52"/>
+          </a:solidFill>
+          <a:ln/>
+        </p:spPr>
+      </p:sp>
+      <p:sp>
+        <p:nvSpPr>
+          <p:cNvPr id="43" name="Text 41"/>
+          <p:cNvSpPr/>
+          <p:nvPr/>
+        </p:nvSpPr>
+        <p:spPr>
+          <a:xfrm>
+            <a:off x="10860144" y="5809547"/>
+            <a:ext cx="6475430" cy="476115"/>
+          </a:xfrm>
+          <a:prstGeom prst="rect">
+            <a:avLst/>
+          </a:prstGeom>
+          <a:noFill/>
+          <a:ln/>
+        </p:spPr>
+        <p:txBody>
+          <a:bodyPr wrap="square" lIns="25400" tIns="25400" rIns="25400" bIns="25400" rtlCol="0" anchor="ctr">
+            <a:normAutofit/>
+          </a:bodyPr>
+          <a:lstStyle/>
+          <a:p>
+            <a:pPr algn="r" indent="0" marL="0">
+              <a:buNone/>
+            </a:pPr>
+            <a:r>
+              <a:rPr lang="en-US" sz="1725" b="1" dirty="0">
+                <a:solidFill>
+                  <a:srgbClr val="1E7A52"/>
+                </a:solidFill>
+                <a:latin typeface="IBM Plex Mono" pitchFamily="34" charset="0"/>
+                <a:ea typeface="IBM Plex Mono" pitchFamily="34" charset="-122"/>
+                <a:cs typeface="IBM Plex Mono" pitchFamily="34" charset="-120"/>
+              </a:rPr>
+              <a:t>1.91×*</a:t>
+            </a:r>
+            <a:endParaRPr lang="en-US" sz="1725" dirty="0"/>
+          </a:p>
+        </p:txBody>
+      </p:sp>
+      <p:sp>
+        <p:nvSpPr>
+          <p:cNvPr id="44" name="Text 42"/>
+          <p:cNvSpPr/>
+          <p:nvPr/>
+        </p:nvSpPr>
+        <p:spPr>
+          <a:xfrm>
+            <a:off x="952385" y="6247562"/>
+            <a:ext cx="628610" cy="325038"/>
+          </a:xfrm>
+          <a:prstGeom prst="rect">
+            <a:avLst/>
+          </a:prstGeom>
+          <a:noFill/>
+          <a:ln/>
+        </p:spPr>
+        <p:txBody>
+          <a:bodyPr wrap="square" lIns="25400" tIns="25400" rIns="25400" bIns="25400" rtlCol="0" anchor="t">
+            <a:normAutofit/>
+          </a:bodyPr>
+          <a:lstStyle/>
+          <a:p>
+            <a:pPr algn="l" indent="0" marL="0">
+              <a:buNone/>
+            </a:pPr>
+            <a:r>
+              <a:rPr lang="en-US" sz="1725" b="1" dirty="0">
+                <a:solidFill>
+                  <a:srgbClr val="1A2430"/>
+                </a:solidFill>
+                <a:latin typeface="IBM Plex Mono" pitchFamily="34" charset="0"/>
+                <a:ea typeface="IBM Plex Mono" pitchFamily="34" charset="-122"/>
+                <a:cs typeface="IBM Plex Mono" pitchFamily="34" charset="-120"/>
+              </a:rPr>
+              <a:t>Q08</a:t>
+            </a:r>
+            <a:endParaRPr lang="en-US" sz="1725" dirty="0"/>
+          </a:p>
+        </p:txBody>
+      </p:sp>
+      <p:sp>
+        <p:nvSpPr>
+          <p:cNvPr id="45" name="Text 43"/>
+          <p:cNvSpPr/>
+          <p:nvPr/>
+        </p:nvSpPr>
+        <p:spPr>
+          <a:xfrm>
+            <a:off x="1638074" y="6264952"/>
+            <a:ext cx="2255154" cy="307648"/>
+          </a:xfrm>
+          <a:prstGeom prst="rect">
+            <a:avLst/>
+          </a:prstGeom>
+          <a:noFill/>
+          <a:ln/>
+        </p:spPr>
+        <p:txBody>
+          <a:bodyPr wrap="square" lIns="25400" tIns="25400" rIns="25400" bIns="25400" rtlCol="0" anchor="t">
+            <a:normAutofit/>
+          </a:bodyPr>
+          <a:lstStyle/>
+          <a:p>
+            <a:pPr algn="l" indent="0" marL="0">
+              <a:buNone/>
+            </a:pPr>
+            <a:r>
+              <a:rPr lang="en-US" sz="1650" dirty="0">
+                <a:solidFill>
+                  <a:srgbClr val="6B655C"/>
+                </a:solidFill>
+                <a:latin typeface="Space Grotesk" pitchFamily="34" charset="0"/>
+                <a:ea typeface="Space Grotesk" pitchFamily="34" charset="-122"/>
+                <a:cs typeface="Space Grotesk" pitchFamily="34" charset="-120"/>
+              </a:rPr>
+              <a:t>Teammates of Messi</a:t>
+            </a:r>
+            <a:endParaRPr lang="en-US" sz="1650" dirty="0"/>
+          </a:p>
+        </p:txBody>
+      </p:sp>
+      <p:sp>
+        <p:nvSpPr>
+          <p:cNvPr id="46" name="Shape 44"/>
+          <p:cNvSpPr/>
+          <p:nvPr/>
+        </p:nvSpPr>
+        <p:spPr>
+          <a:xfrm>
+            <a:off x="7411889" y="6247562"/>
+            <a:ext cx="17390" cy="438015"/>
+          </a:xfrm>
+          <a:prstGeom prst="rect">
+            <a:avLst/>
+          </a:prstGeom>
+          <a:solidFill>
+            <a:srgbClr val="1A2430"/>
+          </a:solidFill>
+          <a:ln/>
+        </p:spPr>
+      </p:sp>
+      <p:sp>
+        <p:nvSpPr>
+          <p:cNvPr id="47" name="Shape 45"/>
+          <p:cNvSpPr/>
+          <p:nvPr/>
+        </p:nvSpPr>
+        <p:spPr>
+          <a:xfrm>
+            <a:off x="7424927" y="6323644"/>
+            <a:ext cx="770807" cy="285715"/>
+          </a:xfrm>
+          <a:prstGeom prst="rect">
+            <a:avLst/>
+          </a:prstGeom>
+          <a:solidFill>
+            <a:srgbClr val="1E7A52"/>
+          </a:solidFill>
+          <a:ln/>
+        </p:spPr>
+      </p:sp>
+      <p:sp>
+        <p:nvSpPr>
+          <p:cNvPr id="48" name="Text 46"/>
+          <p:cNvSpPr/>
+          <p:nvPr/>
+        </p:nvSpPr>
+        <p:spPr>
+          <a:xfrm>
+            <a:off x="10860144" y="6247562"/>
+            <a:ext cx="6475430" cy="476115"/>
+          </a:xfrm>
+          <a:prstGeom prst="rect">
+            <a:avLst/>
+          </a:prstGeom>
+          <a:noFill/>
+          <a:ln/>
+        </p:spPr>
+        <p:txBody>
+          <a:bodyPr wrap="square" lIns="25400" tIns="25400" rIns="25400" bIns="25400" rtlCol="0" anchor="ctr">
+            <a:normAutofit/>
+          </a:bodyPr>
+          <a:lstStyle/>
+          <a:p>
+            <a:pPr algn="r" indent="0" marL="0">
+              <a:buNone/>
+            </a:pPr>
+            <a:r>
+              <a:rPr lang="en-US" sz="1725" b="1" dirty="0">
+                <a:solidFill>
+                  <a:srgbClr val="1E7A52"/>
+                </a:solidFill>
+                <a:latin typeface="IBM Plex Mono" pitchFamily="34" charset="0"/>
+                <a:ea typeface="IBM Plex Mono" pitchFamily="34" charset="-122"/>
+                <a:cs typeface="IBM Plex Mono" pitchFamily="34" charset="-120"/>
+              </a:rPr>
+              <a:t>2.66×*</a:t>
+            </a:r>
+            <a:endParaRPr lang="en-US" sz="1725" dirty="0"/>
+          </a:p>
+        </p:txBody>
+      </p:sp>
+      <p:sp>
+        <p:nvSpPr>
+          <p:cNvPr id="49" name="Text 47"/>
+          <p:cNvSpPr/>
+          <p:nvPr/>
+        </p:nvSpPr>
+        <p:spPr>
+          <a:xfrm>
+            <a:off x="952385" y="6685577"/>
+            <a:ext cx="628610" cy="325038"/>
+          </a:xfrm>
+          <a:prstGeom prst="rect">
+            <a:avLst/>
+          </a:prstGeom>
+          <a:noFill/>
+          <a:ln/>
+        </p:spPr>
+        <p:txBody>
+          <a:bodyPr wrap="square" lIns="25400" tIns="25400" rIns="25400" bIns="25400" rtlCol="0" anchor="t">
+            <a:normAutofit/>
+          </a:bodyPr>
+          <a:lstStyle/>
+          <a:p>
+            <a:pPr algn="l" indent="0" marL="0">
+              <a:buNone/>
+            </a:pPr>
+            <a:r>
+              <a:rPr lang="en-US" sz="1725" b="1" dirty="0">
+                <a:solidFill>
+                  <a:srgbClr val="1A2430"/>
+                </a:solidFill>
+                <a:latin typeface="IBM Plex Mono" pitchFamily="34" charset="0"/>
+                <a:ea typeface="IBM Plex Mono" pitchFamily="34" charset="-122"/>
+                <a:cs typeface="IBM Plex Mono" pitchFamily="34" charset="-120"/>
+              </a:rPr>
+              <a:t>Q09</a:t>
+            </a:r>
+            <a:endParaRPr lang="en-US" sz="1725" dirty="0"/>
+          </a:p>
+        </p:txBody>
+      </p:sp>
+      <p:sp>
+        <p:nvSpPr>
+          <p:cNvPr id="50" name="Text 48"/>
+          <p:cNvSpPr/>
+          <p:nvPr/>
+        </p:nvSpPr>
+        <p:spPr>
+          <a:xfrm>
+            <a:off x="1638074" y="6702968"/>
+            <a:ext cx="1985403" cy="307648"/>
+          </a:xfrm>
+          <a:prstGeom prst="rect">
+            <a:avLst/>
+          </a:prstGeom>
+          <a:noFill/>
+          <a:ln/>
+        </p:spPr>
+        <p:txBody>
+          <a:bodyPr wrap="square" lIns="25400" tIns="25400" rIns="25400" bIns="25400" rtlCol="0" anchor="t">
+            <a:normAutofit/>
+          </a:bodyPr>
+          <a:lstStyle/>
+          <a:p>
+            <a:pPr algn="l" indent="0" marL="0">
+              <a:buNone/>
+            </a:pPr>
+            <a:r>
+              <a:rPr lang="en-US" sz="1650" dirty="0">
+                <a:solidFill>
+                  <a:srgbClr val="6B655C"/>
+                </a:solidFill>
+                <a:latin typeface="Space Grotesk" pitchFamily="34" charset="0"/>
+                <a:ea typeface="Space Grotesk" pitchFamily="34" charset="-122"/>
+                <a:cs typeface="Space Grotesk" pitchFamily="34" charset="-120"/>
+              </a:rPr>
+              <a:t>2-hop teammates</a:t>
+            </a:r>
+            <a:endParaRPr lang="en-US" sz="1650" dirty="0"/>
+          </a:p>
+        </p:txBody>
+      </p:sp>
+      <p:sp>
+        <p:nvSpPr>
+          <p:cNvPr id="51" name="Shape 49"/>
+          <p:cNvSpPr/>
+          <p:nvPr/>
+        </p:nvSpPr>
+        <p:spPr>
+          <a:xfrm>
+            <a:off x="7411889" y="6685577"/>
+            <a:ext cx="17390" cy="438015"/>
+          </a:xfrm>
+          <a:prstGeom prst="rect">
+            <a:avLst/>
+          </a:prstGeom>
+          <a:solidFill>
+            <a:srgbClr val="1A2430"/>
+          </a:solidFill>
+          <a:ln/>
+        </p:spPr>
+      </p:sp>
+      <p:sp>
+        <p:nvSpPr>
+          <p:cNvPr id="52" name="Shape 50"/>
+          <p:cNvSpPr/>
+          <p:nvPr/>
+        </p:nvSpPr>
+        <p:spPr>
+          <a:xfrm>
+            <a:off x="6834984" y="6761659"/>
+            <a:ext cx="580799" cy="285715"/>
           </a:xfrm>
           <a:prstGeom prst="rect">
             <a:avLst/>
@@ -3453,13 +4425,13 @@
       </p:sp>
       <p:sp>
         <p:nvSpPr>
-          <p:cNvPr id="23" name="Text 21"/>
-          <p:cNvSpPr/>
-          <p:nvPr/>
-        </p:nvSpPr>
-        <p:spPr>
-          <a:xfrm>
-            <a:off x="10860144" y="4057485"/>
+          <p:cNvPr id="53" name="Text 51"/>
+          <p:cNvSpPr/>
+          <p:nvPr/>
+        </p:nvSpPr>
+        <p:spPr>
+          <a:xfrm>
+            <a:off x="10860144" y="6685577"/>
             <a:ext cx="6475430" cy="476115"/>
           </a:xfrm>
           <a:prstGeom prst="rect">
@@ -3486,7 +4458,7 @@
                 <a:ea typeface="IBM Plex Mono" pitchFamily="34" charset="-122"/>
                 <a:cs typeface="IBM Plex Mono" pitchFamily="34" charset="-120"/>
               </a:rPr>
-              <a:t>2.11×*</a:t>
+              <a:t>2.09×*</a:t>
             </a:r>
             <a:endParaRPr lang="en-US" sz="1725" dirty="0"/>
           </a:p>
@@ -3494,13 +4466,13 @@
       </p:sp>
       <p:sp>
         <p:nvSpPr>
-          <p:cNvPr id="24" name="Text 22"/>
-          <p:cNvSpPr/>
-          <p:nvPr/>
-        </p:nvSpPr>
-        <p:spPr>
-          <a:xfrm>
-            <a:off x="952385" y="4495500"/>
+          <p:cNvPr id="54" name="Text 52"/>
+          <p:cNvSpPr/>
+          <p:nvPr/>
+        </p:nvSpPr>
+        <p:spPr>
+          <a:xfrm>
+            <a:off x="952385" y="7123593"/>
             <a:ext cx="628610" cy="325038"/>
           </a:xfrm>
           <a:prstGeom prst="rect">
@@ -3527,7 +4499,7 @@
                 <a:ea typeface="IBM Plex Mono" pitchFamily="34" charset="-122"/>
                 <a:cs typeface="IBM Plex Mono" pitchFamily="34" charset="-120"/>
               </a:rPr>
-              <a:t>Q04</a:t>
+              <a:t>Q10</a:t>
             </a:r>
             <a:endParaRPr lang="en-US" sz="1725" dirty="0"/>
           </a:p>
@@ -3535,14 +4507,14 @@
       </p:sp>
       <p:sp>
         <p:nvSpPr>
-          <p:cNvPr id="25" name="Text 23"/>
-          <p:cNvSpPr/>
-          <p:nvPr/>
-        </p:nvSpPr>
-        <p:spPr>
-          <a:xfrm>
-            <a:off x="1638074" y="4512890"/>
-            <a:ext cx="2283251" cy="307648"/>
+          <p:cNvPr id="55" name="Text 53"/>
+          <p:cNvSpPr/>
+          <p:nvPr/>
+        </p:nvSpPr>
+        <p:spPr>
+          <a:xfrm>
+            <a:off x="1638074" y="7140983"/>
+            <a:ext cx="2304920" cy="307648"/>
           </a:xfrm>
           <a:prstGeom prst="rect">
             <a:avLst/>
@@ -3568,7 +4540,7 @@
                 <a:ea typeface="Space Grotesk" pitchFamily="34" charset="-122"/>
                 <a:cs typeface="Space Grotesk" pitchFamily="34" charset="-120"/>
               </a:rPr>
-              <a:t>Home win % by team</a:t>
+              <a:t>Shortest path Messi→Pirlo</a:t>
             </a:r>
             <a:endParaRPr lang="en-US" sz="1650" dirty="0"/>
           </a:p>
@@ -3576,13 +4548,13 @@
       </p:sp>
       <p:sp>
         <p:nvSpPr>
-          <p:cNvPr id="26" name="Shape 24"/>
-          <p:cNvSpPr/>
-          <p:nvPr/>
-        </p:nvSpPr>
-        <p:spPr>
-          <a:xfrm>
-            <a:off x="7411889" y="4495500"/>
+          <p:cNvPr id="56" name="Shape 54"/>
+          <p:cNvSpPr/>
+          <p:nvPr/>
+        </p:nvSpPr>
+        <p:spPr>
+          <a:xfrm>
+            <a:off x="7411889" y="7123593"/>
             <a:ext cx="17390" cy="438015"/>
           </a:xfrm>
           <a:prstGeom prst="rect">
@@ -3596,33 +4568,33 @@
       </p:sp>
       <p:sp>
         <p:nvSpPr>
-          <p:cNvPr id="27" name="Shape 25"/>
-          <p:cNvSpPr/>
-          <p:nvPr/>
-        </p:nvSpPr>
-        <p:spPr>
-          <a:xfrm>
-            <a:off x="7278610" y="4571582"/>
-            <a:ext cx="133280" cy="285715"/>
+          <p:cNvPr id="57" name="Shape 55"/>
+          <p:cNvSpPr/>
+          <p:nvPr/>
+        </p:nvSpPr>
+        <p:spPr>
+          <a:xfrm>
+            <a:off x="7424927" y="7199674"/>
+            <a:ext cx="3181297" cy="285715"/>
           </a:xfrm>
           <a:prstGeom prst="rect">
             <a:avLst/>
           </a:prstGeom>
           <a:solidFill>
-            <a:srgbClr val="33608F"/>
+            <a:srgbClr val="1E7A52"/>
           </a:solidFill>
           <a:ln/>
         </p:spPr>
       </p:sp>
       <p:sp>
         <p:nvSpPr>
-          <p:cNvPr id="28" name="Text 26"/>
-          <p:cNvSpPr/>
-          <p:nvPr/>
-        </p:nvSpPr>
-        <p:spPr>
-          <a:xfrm>
-            <a:off x="10860144" y="4495500"/>
+          <p:cNvPr id="58" name="Text 56"/>
+          <p:cNvSpPr/>
+          <p:nvPr/>
+        </p:nvSpPr>
+        <p:spPr>
+          <a:xfrm>
+            <a:off x="10860144" y="7123593"/>
             <a:ext cx="6475430" cy="476115"/>
           </a:xfrm>
           <a:prstGeom prst="rect">
@@ -3643,13 +4615,13 @@
             <a:r>
               <a:rPr lang="en-US" sz="1725" b="1" dirty="0">
                 <a:solidFill>
-                  <a:srgbClr val="33608F"/>
+                  <a:srgbClr val="1E7A52"/>
                 </a:solidFill>
                 <a:latin typeface="IBM Plex Mono" pitchFamily="34" charset="0"/>
                 <a:ea typeface="IBM Plex Mono" pitchFamily="34" charset="-122"/>
                 <a:cs typeface="IBM Plex Mono" pitchFamily="34" charset="-120"/>
               </a:rPr>
-              <a:t>1.18×*</a:t>
+              <a:t>56.7×*</a:t>
             </a:r>
             <a:endParaRPr lang="en-US" sz="1725" dirty="0"/>
           </a:p>
@@ -3657,13 +4629,13 @@
       </p:sp>
       <p:sp>
         <p:nvSpPr>
-          <p:cNvPr id="29" name="Text 27"/>
-          <p:cNvSpPr/>
-          <p:nvPr/>
-        </p:nvSpPr>
-        <p:spPr>
-          <a:xfrm>
-            <a:off x="952385" y="4933516"/>
+          <p:cNvPr id="59" name="Text 57"/>
+          <p:cNvSpPr/>
+          <p:nvPr/>
+        </p:nvSpPr>
+        <p:spPr>
+          <a:xfrm>
+            <a:off x="952385" y="7561608"/>
             <a:ext cx="628610" cy="325038"/>
           </a:xfrm>
           <a:prstGeom prst="rect">
@@ -3690,7 +4662,7 @@
                 <a:ea typeface="IBM Plex Mono" pitchFamily="34" charset="-122"/>
                 <a:cs typeface="IBM Plex Mono" pitchFamily="34" charset="-120"/>
               </a:rPr>
-              <a:t>Q05</a:t>
+              <a:t>Q11</a:t>
             </a:r>
             <a:endParaRPr lang="en-US" sz="1725" dirty="0"/>
           </a:p>
@@ -3698,14 +4670,14 @@
       </p:sp>
       <p:sp>
         <p:nvSpPr>
-          <p:cNvPr id="30" name="Text 28"/>
-          <p:cNvSpPr/>
-          <p:nvPr/>
-        </p:nvSpPr>
-        <p:spPr>
-          <a:xfrm>
-            <a:off x="1638074" y="4950906"/>
-            <a:ext cx="2304920" cy="307648"/>
+          <p:cNvPr id="60" name="Text 58"/>
+          <p:cNvSpPr/>
+          <p:nvPr/>
+        </p:nvSpPr>
+        <p:spPr>
+          <a:xfrm>
+            <a:off x="1638074" y="7578998"/>
+            <a:ext cx="2162796" cy="307648"/>
           </a:xfrm>
           <a:prstGeom prst="rect">
             <a:avLst/>
@@ -3731,7 +4703,7 @@
                 <a:ea typeface="Space Grotesk" pitchFamily="34" charset="-122"/>
                 <a:cs typeface="Space Grotesk" pitchFamily="34" charset="-120"/>
               </a:rPr>
-              <a:t>Goal-assist partnerships</a:t>
+              <a:t>Bulk UPDATE (write)</a:t>
             </a:r>
             <a:endParaRPr lang="en-US" sz="1650" dirty="0"/>
           </a:p>
@@ -3739,13 +4711,13 @@
       </p:sp>
       <p:sp>
         <p:nvSpPr>
-          <p:cNvPr id="31" name="Shape 29"/>
-          <p:cNvSpPr/>
-          <p:nvPr/>
-        </p:nvSpPr>
-        <p:spPr>
-          <a:xfrm>
-            <a:off x="7411889" y="4933516"/>
+          <p:cNvPr id="61" name="Shape 59"/>
+          <p:cNvSpPr/>
+          <p:nvPr/>
+        </p:nvSpPr>
+        <p:spPr>
+          <a:xfrm>
+            <a:off x="7411889" y="7561608"/>
             <a:ext cx="17390" cy="438015"/>
           </a:xfrm>
           <a:prstGeom prst="rect">
@@ -3759,14 +4731,14 @@
       </p:sp>
       <p:sp>
         <p:nvSpPr>
-          <p:cNvPr id="32" name="Shape 30"/>
-          <p:cNvSpPr/>
-          <p:nvPr/>
-        </p:nvSpPr>
-        <p:spPr>
-          <a:xfrm>
-            <a:off x="7429280" y="5009598"/>
-            <a:ext cx="342777" cy="285715"/>
+          <p:cNvPr id="62" name="Shape 60"/>
+          <p:cNvSpPr/>
+          <p:nvPr/>
+        </p:nvSpPr>
+        <p:spPr>
+          <a:xfrm>
+            <a:off x="7424927" y="7637690"/>
+            <a:ext cx="324694" cy="285715"/>
           </a:xfrm>
           <a:prstGeom prst="rect">
             <a:avLst/>
@@ -3779,13 +4751,13 @@
       </p:sp>
       <p:sp>
         <p:nvSpPr>
-          <p:cNvPr id="33" name="Text 31"/>
-          <p:cNvSpPr/>
-          <p:nvPr/>
-        </p:nvSpPr>
-        <p:spPr>
-          <a:xfrm>
-            <a:off x="10860144" y="4933516"/>
+          <p:cNvPr id="63" name="Text 61"/>
+          <p:cNvSpPr/>
+          <p:nvPr/>
+        </p:nvSpPr>
+        <p:spPr>
+          <a:xfrm>
+            <a:off x="10860144" y="7561608"/>
             <a:ext cx="6475430" cy="476115"/>
           </a:xfrm>
           <a:prstGeom prst="rect">
@@ -3812,7 +4784,7 @@
                 <a:ea typeface="IBM Plex Mono" pitchFamily="34" charset="-122"/>
                 <a:cs typeface="IBM Plex Mono" pitchFamily="34" charset="-120"/>
               </a:rPr>
-              <a:t>1.54×*</a:t>
+              <a:t>1.51×*</a:t>
             </a:r>
             <a:endParaRPr lang="en-US" sz="1725" dirty="0"/>
           </a:p>
@@ -3820,13 +4792,13 @@
       </p:sp>
       <p:sp>
         <p:nvSpPr>
-          <p:cNvPr id="34" name="Text 32"/>
-          <p:cNvSpPr/>
-          <p:nvPr/>
-        </p:nvSpPr>
-        <p:spPr>
-          <a:xfrm>
-            <a:off x="952385" y="5371531"/>
+          <p:cNvPr id="64" name="Text 62"/>
+          <p:cNvSpPr/>
+          <p:nvPr/>
+        </p:nvSpPr>
+        <p:spPr>
+          <a:xfrm>
+            <a:off x="952385" y="7999623"/>
             <a:ext cx="628610" cy="325038"/>
           </a:xfrm>
           <a:prstGeom prst="rect">
@@ -3853,7 +4825,7 @@
                 <a:ea typeface="IBM Plex Mono" pitchFamily="34" charset="-122"/>
                 <a:cs typeface="IBM Plex Mono" pitchFamily="34" charset="-120"/>
               </a:rPr>
-              <a:t>Q06</a:t>
+              <a:t>Q12</a:t>
             </a:r>
             <a:endParaRPr lang="en-US" sz="1725" dirty="0"/>
           </a:p>
@@ -3861,14 +4833,14 @@
       </p:sp>
       <p:sp>
         <p:nvSpPr>
-          <p:cNvPr id="35" name="Text 33"/>
-          <p:cNvSpPr/>
-          <p:nvPr/>
-        </p:nvSpPr>
-        <p:spPr>
-          <a:xfrm>
-            <a:off x="1638074" y="5388921"/>
-            <a:ext cx="2291918" cy="307648"/>
+          <p:cNvPr id="65" name="Text 63"/>
+          <p:cNvSpPr/>
+          <p:nvPr/>
+        </p:nvSpPr>
+        <p:spPr>
+          <a:xfrm>
+            <a:off x="1638074" y="8017014"/>
+            <a:ext cx="2304920" cy="307648"/>
           </a:xfrm>
           <a:prstGeom prst="rect">
             <a:avLst/>
@@ -3894,7 +4866,7 @@
                 <a:ea typeface="Space Grotesk" pitchFamily="34" charset="-122"/>
                 <a:cs typeface="Space Grotesk" pitchFamily="34" charset="-120"/>
               </a:rPr>
-              <a:t>Cards vs Real Madrid</a:t>
+              <a:t>Schema evolution (write)</a:t>
             </a:r>
             <a:endParaRPr lang="en-US" sz="1650" dirty="0"/>
           </a:p>
@@ -3902,13 +4874,13 @@
       </p:sp>
       <p:sp>
         <p:nvSpPr>
-          <p:cNvPr id="36" name="Shape 34"/>
-          <p:cNvSpPr/>
-          <p:nvPr/>
-        </p:nvSpPr>
-        <p:spPr>
-          <a:xfrm>
-            <a:off x="7411889" y="5371531"/>
+          <p:cNvPr id="66" name="Shape 64"/>
+          <p:cNvSpPr/>
+          <p:nvPr/>
+        </p:nvSpPr>
+        <p:spPr>
+          <a:xfrm>
+            <a:off x="7411889" y="7999623"/>
             <a:ext cx="17390" cy="438015"/>
           </a:xfrm>
           <a:prstGeom prst="rect">
@@ -3922,14 +4894,14 @@
       </p:sp>
       <p:sp>
         <p:nvSpPr>
-          <p:cNvPr id="37" name="Shape 35"/>
-          <p:cNvSpPr/>
-          <p:nvPr/>
-        </p:nvSpPr>
-        <p:spPr>
-          <a:xfrm>
-            <a:off x="7429280" y="5447613"/>
-            <a:ext cx="923854" cy="285715"/>
+          <p:cNvPr id="67" name="Shape 65"/>
+          <p:cNvSpPr/>
+          <p:nvPr/>
+        </p:nvSpPr>
+        <p:spPr>
+          <a:xfrm>
+            <a:off x="7424927" y="8075705"/>
+            <a:ext cx="1183285" cy="285715"/>
           </a:xfrm>
           <a:prstGeom prst="rect">
             <a:avLst/>
@@ -3942,13 +4914,13 @@
       </p:sp>
       <p:sp>
         <p:nvSpPr>
-          <p:cNvPr id="38" name="Text 36"/>
-          <p:cNvSpPr/>
-          <p:nvPr/>
-        </p:nvSpPr>
-        <p:spPr>
-          <a:xfrm>
-            <a:off x="10860144" y="5371531"/>
+          <p:cNvPr id="68" name="Text 66"/>
+          <p:cNvSpPr/>
+          <p:nvPr/>
+        </p:nvSpPr>
+        <p:spPr>
+          <a:xfrm>
+            <a:off x="10860144" y="7999623"/>
             <a:ext cx="6475430" cy="476115"/>
           </a:xfrm>
           <a:prstGeom prst="rect">
@@ -3975,7 +4947,7 @@
                 <a:ea typeface="IBM Plex Mono" pitchFamily="34" charset="-122"/>
                 <a:cs typeface="IBM Plex Mono" pitchFamily="34" charset="-120"/>
               </a:rPr>
-              <a:t>3.24×*</a:t>
+              <a:t>4.49×*</a:t>
             </a:r>
             <a:endParaRPr lang="en-US" sz="1725" dirty="0"/>
           </a:p>
@@ -3983,1100 +4955,122 @@
       </p:sp>
       <p:sp>
         <p:nvSpPr>
-          <p:cNvPr id="39" name="Text 37"/>
-          <p:cNvSpPr/>
-          <p:nvPr/>
-        </p:nvSpPr>
-        <p:spPr>
-          <a:xfrm>
-            <a:off x="952385" y="5809547"/>
-            <a:ext cx="628610" cy="325038"/>
-          </a:xfrm>
-          <a:prstGeom prst="rect">
-            <a:avLst/>
-          </a:prstGeom>
-          <a:noFill/>
-          <a:ln/>
-        </p:spPr>
-        <p:txBody>
-          <a:bodyPr wrap="square" lIns="25400" tIns="25400" rIns="25400" bIns="25400" rtlCol="0" anchor="t">
-            <a:normAutofit/>
-          </a:bodyPr>
-          <a:lstStyle/>
-          <a:p>
-            <a:pPr algn="l" indent="0" marL="0">
-              <a:buNone/>
-            </a:pPr>
-            <a:r>
-              <a:rPr lang="en-US" sz="1725" b="1" dirty="0">
-                <a:solidFill>
-                  <a:srgbClr val="1A2430"/>
+          <p:cNvPr id="69" name="Text 67"/>
+          <p:cNvSpPr/>
+          <p:nvPr/>
+        </p:nvSpPr>
+        <p:spPr>
+          <a:xfrm>
+            <a:off x="952385" y="8818593"/>
+            <a:ext cx="2341086" cy="316343"/>
+          </a:xfrm>
+          <a:prstGeom prst="rect">
+            <a:avLst/>
+          </a:prstGeom>
+          <a:noFill/>
+          <a:ln/>
+        </p:spPr>
+        <p:txBody>
+          <a:bodyPr wrap="square" lIns="25400" tIns="25400" rIns="25400" bIns="25400" rtlCol="0" anchor="t">
+            <a:normAutofit/>
+          </a:bodyPr>
+          <a:lstStyle/>
+          <a:p>
+            <a:pPr algn="l" indent="0" marL="0">
+              <a:buNone/>
+            </a:pPr>
+            <a:r>
+              <a:rPr lang="en-US" sz="1725" dirty="0">
+                <a:solidFill>
+                  <a:srgbClr val="6B655C"/>
+                </a:solidFill>
+                <a:latin typeface="Space Grotesk" pitchFamily="34" charset="0"/>
+                <a:ea typeface="Space Grotesk" pitchFamily="34" charset="-122"/>
+                <a:cs typeface="Space Grotesk" pitchFamily="34" charset="-120"/>
+              </a:rPr>
+              <a:t>Postgres wins (2)</a:t>
+            </a:r>
+            <a:endParaRPr lang="en-US" sz="1725" dirty="0"/>
+          </a:p>
+        </p:txBody>
+      </p:sp>
+      <p:sp>
+        <p:nvSpPr>
+          <p:cNvPr id="70" name="Text 68"/>
+          <p:cNvSpPr/>
+          <p:nvPr/>
+        </p:nvSpPr>
+        <p:spPr>
+          <a:xfrm>
+            <a:off x="3556837" y="8818593"/>
+            <a:ext cx="1974045" cy="316343"/>
+          </a:xfrm>
+          <a:prstGeom prst="rect">
+            <a:avLst/>
+          </a:prstGeom>
+          <a:noFill/>
+          <a:ln/>
+        </p:spPr>
+        <p:txBody>
+          <a:bodyPr wrap="square" lIns="25400" tIns="25400" rIns="25400" bIns="25400" rtlCol="0" anchor="t">
+            <a:normAutofit/>
+          </a:bodyPr>
+          <a:lstStyle/>
+          <a:p>
+            <a:pPr algn="l" indent="0" marL="0">
+              <a:buNone/>
+            </a:pPr>
+            <a:r>
+              <a:rPr lang="en-US" sz="1725" dirty="0">
+                <a:solidFill>
+                  <a:srgbClr val="6B655C"/>
+                </a:solidFill>
+                <a:latin typeface="Space Grotesk" pitchFamily="34" charset="0"/>
+                <a:ea typeface="Space Grotesk" pitchFamily="34" charset="-122"/>
+                <a:cs typeface="Space Grotesk" pitchFamily="34" charset="-120"/>
+              </a:rPr>
+              <a:t>Neo4j wins (9) · not significant (1)</a:t>
+            </a:r>
+            <a:endParaRPr lang="en-US" sz="1725" dirty="0"/>
+          </a:p>
+        </p:txBody>
+      </p:sp>
+      <p:sp>
+        <p:nvSpPr>
+          <p:cNvPr id="71" name="Text 69"/>
+          <p:cNvSpPr/>
+          <p:nvPr/>
+        </p:nvSpPr>
+        <p:spPr>
+          <a:xfrm>
+            <a:off x="5827616" y="8827288"/>
+            <a:ext cx="10031477" cy="298953"/>
+          </a:xfrm>
+          <a:prstGeom prst="rect">
+            <a:avLst/>
+          </a:prstGeom>
+          <a:noFill/>
+          <a:ln/>
+        </p:spPr>
+        <p:txBody>
+          <a:bodyPr wrap="square" lIns="25400" tIns="25400" rIns="25400" bIns="25400" rtlCol="0" anchor="t">
+            <a:normAutofit/>
+          </a:bodyPr>
+          <a:lstStyle/>
+          <a:p>
+            <a:pPr algn="l" indent="0" marL="0">
+              <a:buNone/>
+            </a:pPr>
+            <a:r>
+              <a:rPr lang="en-US" sz="1575" dirty="0">
+                <a:solidFill>
+                  <a:srgbClr val="6B655C"/>
                 </a:solidFill>
                 <a:latin typeface="IBM Plex Mono" pitchFamily="34" charset="0"/>
                 <a:ea typeface="IBM Plex Mono" pitchFamily="34" charset="-122"/>
                 <a:cs typeface="IBM Plex Mono" pitchFamily="34" charset="-120"/>
               </a:rPr>
-              <a:t>Q07</a:t>
-            </a:r>
-            <a:endParaRPr lang="en-US" sz="1725" dirty="0"/>
-          </a:p>
-        </p:txBody>
-      </p:sp>
-      <p:sp>
-        <p:nvSpPr>
-          <p:cNvPr id="40" name="Text 38"/>
-          <p:cNvSpPr/>
-          <p:nvPr/>
-        </p:nvSpPr>
-        <p:spPr>
-          <a:xfrm>
-            <a:off x="1638074" y="5826937"/>
-            <a:ext cx="2304920" cy="307648"/>
-          </a:xfrm>
-          <a:prstGeom prst="rect">
-            <a:avLst/>
-          </a:prstGeom>
-          <a:noFill/>
-          <a:ln/>
-        </p:spPr>
-        <p:txBody>
-          <a:bodyPr wrap="square" lIns="25400" tIns="25400" rIns="25400" bIns="25400" rtlCol="0" anchor="t">
-            <a:normAutofit/>
-          </a:bodyPr>
-          <a:lstStyle/>
-          <a:p>
-            <a:pPr algn="l" indent="0" marL="0">
-              <a:buNone/>
-            </a:pPr>
-            <a:r>
-              <a:rPr lang="en-US" sz="1650" dirty="0">
-                <a:solidFill>
-                  <a:srgbClr val="6B655C"/>
-                </a:solidFill>
-                <a:latin typeface="Space Grotesk" pitchFamily="34" charset="0"/>
-                <a:ea typeface="Space Grotesk" pitchFamily="34" charset="-122"/>
-                <a:cs typeface="Space Grotesk" pitchFamily="34" charset="-120"/>
-              </a:rPr>
-              <a:t>Players in all 8 seasons</a:t>
-            </a:r>
-            <a:endParaRPr lang="en-US" sz="1650" dirty="0"/>
-          </a:p>
-        </p:txBody>
-      </p:sp>
-      <p:sp>
-        <p:nvSpPr>
-          <p:cNvPr id="41" name="Shape 39"/>
-          <p:cNvSpPr/>
-          <p:nvPr/>
-        </p:nvSpPr>
-        <p:spPr>
-          <a:xfrm>
-            <a:off x="7411889" y="5809547"/>
-            <a:ext cx="17390" cy="438015"/>
-          </a:xfrm>
-          <a:prstGeom prst="rect">
-            <a:avLst/>
-          </a:prstGeom>
-          <a:solidFill>
-            <a:srgbClr val="1A2430"/>
-          </a:solidFill>
-          <a:ln/>
-        </p:spPr>
-      </p:sp>
-      <p:sp>
-        <p:nvSpPr>
-          <p:cNvPr id="42" name="Shape 40"/>
-          <p:cNvSpPr/>
-          <p:nvPr/>
-        </p:nvSpPr>
-        <p:spPr>
-          <a:xfrm>
-            <a:off x="7429280" y="5885629"/>
-            <a:ext cx="1438223" cy="285715"/>
-          </a:xfrm>
-          <a:prstGeom prst="rect">
-            <a:avLst/>
-          </a:prstGeom>
-          <a:solidFill>
-            <a:srgbClr val="1E7A52"/>
-          </a:solidFill>
-          <a:ln/>
-        </p:spPr>
-      </p:sp>
-      <p:sp>
-        <p:nvSpPr>
-          <p:cNvPr id="43" name="Text 41"/>
-          <p:cNvSpPr/>
-          <p:nvPr/>
-        </p:nvSpPr>
-        <p:spPr>
-          <a:xfrm>
-            <a:off x="10860144" y="5809547"/>
-            <a:ext cx="6475430" cy="476115"/>
-          </a:xfrm>
-          <a:prstGeom prst="rect">
-            <a:avLst/>
-          </a:prstGeom>
-          <a:noFill/>
-          <a:ln/>
-        </p:spPr>
-        <p:txBody>
-          <a:bodyPr wrap="square" lIns="25400" tIns="25400" rIns="25400" bIns="25400" rtlCol="0" anchor="ctr">
-            <a:normAutofit/>
-          </a:bodyPr>
-          <a:lstStyle/>
-          <a:p>
-            <a:pPr algn="r" indent="0" marL="0">
-              <a:buNone/>
-            </a:pPr>
-            <a:r>
-              <a:rPr lang="en-US" sz="1725" b="1" dirty="0">
-                <a:solidFill>
-                  <a:srgbClr val="1E7A52"/>
-                </a:solidFill>
-                <a:latin typeface="IBM Plex Mono" pitchFamily="34" charset="0"/>
-                <a:ea typeface="IBM Plex Mono" pitchFamily="34" charset="-122"/>
-                <a:cs typeface="IBM Plex Mono" pitchFamily="34" charset="-120"/>
-              </a:rPr>
-              <a:t>6.23×*</a:t>
-            </a:r>
-            <a:endParaRPr lang="en-US" sz="1725" dirty="0"/>
-          </a:p>
-        </p:txBody>
-      </p:sp>
-      <p:sp>
-        <p:nvSpPr>
-          <p:cNvPr id="44" name="Text 42"/>
-          <p:cNvSpPr/>
-          <p:nvPr/>
-        </p:nvSpPr>
-        <p:spPr>
-          <a:xfrm>
-            <a:off x="952385" y="6247562"/>
-            <a:ext cx="628610" cy="325038"/>
-          </a:xfrm>
-          <a:prstGeom prst="rect">
-            <a:avLst/>
-          </a:prstGeom>
-          <a:noFill/>
-          <a:ln/>
-        </p:spPr>
-        <p:txBody>
-          <a:bodyPr wrap="square" lIns="25400" tIns="25400" rIns="25400" bIns="25400" rtlCol="0" anchor="t">
-            <a:normAutofit/>
-          </a:bodyPr>
-          <a:lstStyle/>
-          <a:p>
-            <a:pPr algn="l" indent="0" marL="0">
-              <a:buNone/>
-            </a:pPr>
-            <a:r>
-              <a:rPr lang="en-US" sz="1725" b="1" dirty="0">
-                <a:solidFill>
-                  <a:srgbClr val="1A2430"/>
-                </a:solidFill>
-                <a:latin typeface="IBM Plex Mono" pitchFamily="34" charset="0"/>
-                <a:ea typeface="IBM Plex Mono" pitchFamily="34" charset="-122"/>
-                <a:cs typeface="IBM Plex Mono" pitchFamily="34" charset="-120"/>
-              </a:rPr>
-              <a:t>Q08</a:t>
-            </a:r>
-            <a:endParaRPr lang="en-US" sz="1725" dirty="0"/>
-          </a:p>
-        </p:txBody>
-      </p:sp>
-      <p:sp>
-        <p:nvSpPr>
-          <p:cNvPr id="45" name="Text 43"/>
-          <p:cNvSpPr/>
-          <p:nvPr/>
-        </p:nvSpPr>
-        <p:spPr>
-          <a:xfrm>
-            <a:off x="1638074" y="6264952"/>
-            <a:ext cx="2255154" cy="307648"/>
-          </a:xfrm>
-          <a:prstGeom prst="rect">
-            <a:avLst/>
-          </a:prstGeom>
-          <a:noFill/>
-          <a:ln/>
-        </p:spPr>
-        <p:txBody>
-          <a:bodyPr wrap="square" lIns="25400" tIns="25400" rIns="25400" bIns="25400" rtlCol="0" anchor="t">
-            <a:normAutofit/>
-          </a:bodyPr>
-          <a:lstStyle/>
-          <a:p>
-            <a:pPr algn="l" indent="0" marL="0">
-              <a:buNone/>
-            </a:pPr>
-            <a:r>
-              <a:rPr lang="en-US" sz="1650" dirty="0">
-                <a:solidFill>
-                  <a:srgbClr val="6B655C"/>
-                </a:solidFill>
-                <a:latin typeface="Space Grotesk" pitchFamily="34" charset="0"/>
-                <a:ea typeface="Space Grotesk" pitchFamily="34" charset="-122"/>
-                <a:cs typeface="Space Grotesk" pitchFamily="34" charset="-120"/>
-              </a:rPr>
-              <a:t>Teammates of Messi</a:t>
-            </a:r>
-            <a:endParaRPr lang="en-US" sz="1650" dirty="0"/>
-          </a:p>
-        </p:txBody>
-      </p:sp>
-      <p:sp>
-        <p:nvSpPr>
-          <p:cNvPr id="46" name="Shape 44"/>
-          <p:cNvSpPr/>
-          <p:nvPr/>
-        </p:nvSpPr>
-        <p:spPr>
-          <a:xfrm>
-            <a:off x="7411889" y="6247562"/>
-            <a:ext cx="17390" cy="438015"/>
-          </a:xfrm>
-          <a:prstGeom prst="rect">
-            <a:avLst/>
-          </a:prstGeom>
-          <a:solidFill>
-            <a:srgbClr val="1A2430"/>
-          </a:solidFill>
-          <a:ln/>
-        </p:spPr>
-      </p:sp>
-      <p:sp>
-        <p:nvSpPr>
-          <p:cNvPr id="47" name="Shape 45"/>
-          <p:cNvSpPr/>
-          <p:nvPr/>
-        </p:nvSpPr>
-        <p:spPr>
-          <a:xfrm>
-            <a:off x="7429280" y="6323644"/>
-            <a:ext cx="409485" cy="285715"/>
-          </a:xfrm>
-          <a:prstGeom prst="rect">
-            <a:avLst/>
-          </a:prstGeom>
-          <a:solidFill>
-            <a:srgbClr val="1E7A52"/>
-          </a:solidFill>
-          <a:ln/>
-        </p:spPr>
-      </p:sp>
-      <p:sp>
-        <p:nvSpPr>
-          <p:cNvPr id="48" name="Text 46"/>
-          <p:cNvSpPr/>
-          <p:nvPr/>
-        </p:nvSpPr>
-        <p:spPr>
-          <a:xfrm>
-            <a:off x="10860144" y="6247562"/>
-            <a:ext cx="6475430" cy="476115"/>
-          </a:xfrm>
-          <a:prstGeom prst="rect">
-            <a:avLst/>
-          </a:prstGeom>
-          <a:noFill/>
-          <a:ln/>
-        </p:spPr>
-        <p:txBody>
-          <a:bodyPr wrap="square" lIns="25400" tIns="25400" rIns="25400" bIns="25400" rtlCol="0" anchor="ctr">
-            <a:normAutofit/>
-          </a:bodyPr>
-          <a:lstStyle/>
-          <a:p>
-            <a:pPr algn="r" indent="0" marL="0">
-              <a:buNone/>
-            </a:pPr>
-            <a:r>
-              <a:rPr lang="en-US" sz="1725" b="1" dirty="0">
-                <a:solidFill>
-                  <a:srgbClr val="1E7A52"/>
-                </a:solidFill>
-                <a:latin typeface="IBM Plex Mono" pitchFamily="34" charset="0"/>
-                <a:ea typeface="IBM Plex Mono" pitchFamily="34" charset="-122"/>
-                <a:cs typeface="IBM Plex Mono" pitchFamily="34" charset="-120"/>
-              </a:rPr>
-              <a:t>1.69×*</a:t>
-            </a:r>
-            <a:endParaRPr lang="en-US" sz="1725" dirty="0"/>
-          </a:p>
-        </p:txBody>
-      </p:sp>
-      <p:sp>
-        <p:nvSpPr>
-          <p:cNvPr id="49" name="Text 47"/>
-          <p:cNvSpPr/>
-          <p:nvPr/>
-        </p:nvSpPr>
-        <p:spPr>
-          <a:xfrm>
-            <a:off x="952385" y="6685577"/>
-            <a:ext cx="628610" cy="325038"/>
-          </a:xfrm>
-          <a:prstGeom prst="rect">
-            <a:avLst/>
-          </a:prstGeom>
-          <a:noFill/>
-          <a:ln/>
-        </p:spPr>
-        <p:txBody>
-          <a:bodyPr wrap="square" lIns="25400" tIns="25400" rIns="25400" bIns="25400" rtlCol="0" anchor="t">
-            <a:normAutofit/>
-          </a:bodyPr>
-          <a:lstStyle/>
-          <a:p>
-            <a:pPr algn="l" indent="0" marL="0">
-              <a:buNone/>
-            </a:pPr>
-            <a:r>
-              <a:rPr lang="en-US" sz="1725" b="1" dirty="0">
-                <a:solidFill>
-                  <a:srgbClr val="1A2430"/>
-                </a:solidFill>
-                <a:latin typeface="IBM Plex Mono" pitchFamily="34" charset="0"/>
-                <a:ea typeface="IBM Plex Mono" pitchFamily="34" charset="-122"/>
-                <a:cs typeface="IBM Plex Mono" pitchFamily="34" charset="-120"/>
-              </a:rPr>
-              <a:t>Q09</a:t>
-            </a:r>
-            <a:endParaRPr lang="en-US" sz="1725" dirty="0"/>
-          </a:p>
-        </p:txBody>
-      </p:sp>
-      <p:sp>
-        <p:nvSpPr>
-          <p:cNvPr id="50" name="Text 48"/>
-          <p:cNvSpPr/>
-          <p:nvPr/>
-        </p:nvSpPr>
-        <p:spPr>
-          <a:xfrm>
-            <a:off x="1638074" y="6702968"/>
-            <a:ext cx="1985403" cy="307648"/>
-          </a:xfrm>
-          <a:prstGeom prst="rect">
-            <a:avLst/>
-          </a:prstGeom>
-          <a:noFill/>
-          <a:ln/>
-        </p:spPr>
-        <p:txBody>
-          <a:bodyPr wrap="square" lIns="25400" tIns="25400" rIns="25400" bIns="25400" rtlCol="0" anchor="t">
-            <a:normAutofit/>
-          </a:bodyPr>
-          <a:lstStyle/>
-          <a:p>
-            <a:pPr algn="l" indent="0" marL="0">
-              <a:buNone/>
-            </a:pPr>
-            <a:r>
-              <a:rPr lang="en-US" sz="1650" dirty="0">
-                <a:solidFill>
-                  <a:srgbClr val="6B655C"/>
-                </a:solidFill>
-                <a:latin typeface="Space Grotesk" pitchFamily="34" charset="0"/>
-                <a:ea typeface="Space Grotesk" pitchFamily="34" charset="-122"/>
-                <a:cs typeface="Space Grotesk" pitchFamily="34" charset="-120"/>
-              </a:rPr>
-              <a:t>2-hop teammates</a:t>
-            </a:r>
-            <a:endParaRPr lang="en-US" sz="1650" dirty="0"/>
-          </a:p>
-        </p:txBody>
-      </p:sp>
-      <p:sp>
-        <p:nvSpPr>
-          <p:cNvPr id="51" name="Shape 49"/>
-          <p:cNvSpPr/>
-          <p:nvPr/>
-        </p:nvSpPr>
-        <p:spPr>
-          <a:xfrm>
-            <a:off x="7411889" y="6685577"/>
-            <a:ext cx="17390" cy="438015"/>
-          </a:xfrm>
-          <a:prstGeom prst="rect">
-            <a:avLst/>
-          </a:prstGeom>
-          <a:solidFill>
-            <a:srgbClr val="1A2430"/>
-          </a:solidFill>
-          <a:ln/>
-        </p:spPr>
-      </p:sp>
-      <p:sp>
-        <p:nvSpPr>
-          <p:cNvPr id="52" name="Shape 50"/>
-          <p:cNvSpPr/>
-          <p:nvPr/>
-        </p:nvSpPr>
-        <p:spPr>
-          <a:xfrm>
-            <a:off x="6773751" y="6761659"/>
-            <a:ext cx="638138" cy="285715"/>
-          </a:xfrm>
-          <a:prstGeom prst="rect">
-            <a:avLst/>
-          </a:prstGeom>
-          <a:solidFill>
-            <a:srgbClr val="33608F"/>
-          </a:solidFill>
-          <a:ln/>
-        </p:spPr>
-      </p:sp>
-      <p:sp>
-        <p:nvSpPr>
-          <p:cNvPr id="53" name="Text 51"/>
-          <p:cNvSpPr/>
-          <p:nvPr/>
-        </p:nvSpPr>
-        <p:spPr>
-          <a:xfrm>
-            <a:off x="10860144" y="6685577"/>
-            <a:ext cx="6475430" cy="476115"/>
-          </a:xfrm>
-          <a:prstGeom prst="rect">
-            <a:avLst/>
-          </a:prstGeom>
-          <a:noFill/>
-          <a:ln/>
-        </p:spPr>
-        <p:txBody>
-          <a:bodyPr wrap="square" lIns="25400" tIns="25400" rIns="25400" bIns="25400" rtlCol="0" anchor="ctr">
-            <a:normAutofit/>
-          </a:bodyPr>
-          <a:lstStyle/>
-          <a:p>
-            <a:pPr algn="r" indent="0" marL="0">
-              <a:buNone/>
-            </a:pPr>
-            <a:r>
-              <a:rPr lang="en-US" sz="1725" b="1" dirty="0">
-                <a:solidFill>
-                  <a:srgbClr val="33608F"/>
-                </a:solidFill>
-                <a:latin typeface="IBM Plex Mono" pitchFamily="34" charset="0"/>
-                <a:ea typeface="IBM Plex Mono" pitchFamily="34" charset="-122"/>
-                <a:cs typeface="IBM Plex Mono" pitchFamily="34" charset="-120"/>
-              </a:rPr>
-              <a:t>2.25×*</a:t>
-            </a:r>
-            <a:endParaRPr lang="en-US" sz="1725" dirty="0"/>
-          </a:p>
-        </p:txBody>
-      </p:sp>
-      <p:sp>
-        <p:nvSpPr>
-          <p:cNvPr id="54" name="Text 52"/>
-          <p:cNvSpPr/>
-          <p:nvPr/>
-        </p:nvSpPr>
-        <p:spPr>
-          <a:xfrm>
-            <a:off x="952385" y="7123593"/>
-            <a:ext cx="628610" cy="325038"/>
-          </a:xfrm>
-          <a:prstGeom prst="rect">
-            <a:avLst/>
-          </a:prstGeom>
-          <a:noFill/>
-          <a:ln/>
-        </p:spPr>
-        <p:txBody>
-          <a:bodyPr wrap="square" lIns="25400" tIns="25400" rIns="25400" bIns="25400" rtlCol="0" anchor="t">
-            <a:normAutofit/>
-          </a:bodyPr>
-          <a:lstStyle/>
-          <a:p>
-            <a:pPr algn="l" indent="0" marL="0">
-              <a:buNone/>
-            </a:pPr>
-            <a:r>
-              <a:rPr lang="en-US" sz="1725" b="1" dirty="0">
-                <a:solidFill>
-                  <a:srgbClr val="1A2430"/>
-                </a:solidFill>
-                <a:latin typeface="IBM Plex Mono" pitchFamily="34" charset="0"/>
-                <a:ea typeface="IBM Plex Mono" pitchFamily="34" charset="-122"/>
-                <a:cs typeface="IBM Plex Mono" pitchFamily="34" charset="-120"/>
-              </a:rPr>
-              <a:t>Q10</a:t>
-            </a:r>
-            <a:endParaRPr lang="en-US" sz="1725" dirty="0"/>
-          </a:p>
-        </p:txBody>
-      </p:sp>
-      <p:sp>
-        <p:nvSpPr>
-          <p:cNvPr id="55" name="Text 53"/>
-          <p:cNvSpPr/>
-          <p:nvPr/>
-        </p:nvSpPr>
-        <p:spPr>
-          <a:xfrm>
-            <a:off x="1638074" y="7140983"/>
-            <a:ext cx="2304920" cy="307648"/>
-          </a:xfrm>
-          <a:prstGeom prst="rect">
-            <a:avLst/>
-          </a:prstGeom>
-          <a:noFill/>
-          <a:ln/>
-        </p:spPr>
-        <p:txBody>
-          <a:bodyPr wrap="square" lIns="25400" tIns="25400" rIns="25400" bIns="25400" rtlCol="0" anchor="t">
-            <a:normAutofit/>
-          </a:bodyPr>
-          <a:lstStyle/>
-          <a:p>
-            <a:pPr algn="l" indent="0" marL="0">
-              <a:buNone/>
-            </a:pPr>
-            <a:r>
-              <a:rPr lang="en-US" sz="1650" dirty="0">
-                <a:solidFill>
-                  <a:srgbClr val="6B655C"/>
-                </a:solidFill>
-                <a:latin typeface="Space Grotesk" pitchFamily="34" charset="0"/>
-                <a:ea typeface="Space Grotesk" pitchFamily="34" charset="-122"/>
-                <a:cs typeface="Space Grotesk" pitchFamily="34" charset="-120"/>
-              </a:rPr>
-              <a:t>Shortest path Messi→Pirlo</a:t>
-            </a:r>
-            <a:endParaRPr lang="en-US" sz="1650" dirty="0"/>
-          </a:p>
-        </p:txBody>
-      </p:sp>
-      <p:sp>
-        <p:nvSpPr>
-          <p:cNvPr id="56" name="Shape 54"/>
-          <p:cNvSpPr/>
-          <p:nvPr/>
-        </p:nvSpPr>
-        <p:spPr>
-          <a:xfrm>
-            <a:off x="7411889" y="7123593"/>
-            <a:ext cx="17390" cy="438015"/>
-          </a:xfrm>
-          <a:prstGeom prst="rect">
-            <a:avLst/>
-          </a:prstGeom>
-          <a:solidFill>
-            <a:srgbClr val="1A2430"/>
-          </a:solidFill>
-          <a:ln/>
-        </p:spPr>
-      </p:sp>
-      <p:sp>
-        <p:nvSpPr>
-          <p:cNvPr id="57" name="Shape 55"/>
-          <p:cNvSpPr/>
-          <p:nvPr/>
-        </p:nvSpPr>
-        <p:spPr>
-          <a:xfrm>
-            <a:off x="7429280" y="7199674"/>
-            <a:ext cx="3543251" cy="285715"/>
-          </a:xfrm>
-          <a:prstGeom prst="rect">
-            <a:avLst/>
-          </a:prstGeom>
-          <a:solidFill>
-            <a:srgbClr val="1E7A52"/>
-          </a:solidFill>
-          <a:ln/>
-        </p:spPr>
-      </p:sp>
-      <p:sp>
-        <p:nvSpPr>
-          <p:cNvPr id="58" name="Text 56"/>
-          <p:cNvSpPr/>
-          <p:nvPr/>
-        </p:nvSpPr>
-        <p:spPr>
-          <a:xfrm>
-            <a:off x="10860144" y="7123593"/>
-            <a:ext cx="6475430" cy="476115"/>
-          </a:xfrm>
-          <a:prstGeom prst="rect">
-            <a:avLst/>
-          </a:prstGeom>
-          <a:noFill/>
-          <a:ln/>
-        </p:spPr>
-        <p:txBody>
-          <a:bodyPr wrap="square" lIns="25400" tIns="25400" rIns="25400" bIns="25400" rtlCol="0" anchor="ctr">
-            <a:normAutofit/>
-          </a:bodyPr>
-          <a:lstStyle/>
-          <a:p>
-            <a:pPr algn="r" indent="0" marL="0">
-              <a:buNone/>
-            </a:pPr>
-            <a:r>
-              <a:rPr lang="en-US" sz="1725" b="1" dirty="0">
-                <a:solidFill>
-                  <a:srgbClr val="1E7A52"/>
-                </a:solidFill>
-                <a:latin typeface="IBM Plex Mono" pitchFamily="34" charset="0"/>
-                <a:ea typeface="IBM Plex Mono" pitchFamily="34" charset="-122"/>
-                <a:cs typeface="IBM Plex Mono" pitchFamily="34" charset="-120"/>
-              </a:rPr>
-              <a:t>89.31×*</a:t>
-            </a:r>
-            <a:endParaRPr lang="en-US" sz="1725" dirty="0"/>
-          </a:p>
-        </p:txBody>
-      </p:sp>
-      <p:sp>
-        <p:nvSpPr>
-          <p:cNvPr id="59" name="Text 57"/>
-          <p:cNvSpPr/>
-          <p:nvPr/>
-        </p:nvSpPr>
-        <p:spPr>
-          <a:xfrm>
-            <a:off x="952385" y="7561608"/>
-            <a:ext cx="628610" cy="325038"/>
-          </a:xfrm>
-          <a:prstGeom prst="rect">
-            <a:avLst/>
-          </a:prstGeom>
-          <a:noFill/>
-          <a:ln/>
-        </p:spPr>
-        <p:txBody>
-          <a:bodyPr wrap="square" lIns="25400" tIns="25400" rIns="25400" bIns="25400" rtlCol="0" anchor="t">
-            <a:normAutofit/>
-          </a:bodyPr>
-          <a:lstStyle/>
-          <a:p>
-            <a:pPr algn="l" indent="0" marL="0">
-              <a:buNone/>
-            </a:pPr>
-            <a:r>
-              <a:rPr lang="en-US" sz="1725" b="1" dirty="0">
-                <a:solidFill>
-                  <a:srgbClr val="1A2430"/>
-                </a:solidFill>
-                <a:latin typeface="IBM Plex Mono" pitchFamily="34" charset="0"/>
-                <a:ea typeface="IBM Plex Mono" pitchFamily="34" charset="-122"/>
-                <a:cs typeface="IBM Plex Mono" pitchFamily="34" charset="-120"/>
-              </a:rPr>
-              <a:t>Q11</a:t>
-            </a:r>
-            <a:endParaRPr lang="en-US" sz="1725" dirty="0"/>
-          </a:p>
-        </p:txBody>
-      </p:sp>
-      <p:sp>
-        <p:nvSpPr>
-          <p:cNvPr id="60" name="Text 58"/>
-          <p:cNvSpPr/>
-          <p:nvPr/>
-        </p:nvSpPr>
-        <p:spPr>
-          <a:xfrm>
-            <a:off x="1638074" y="7578998"/>
-            <a:ext cx="2162796" cy="307648"/>
-          </a:xfrm>
-          <a:prstGeom prst="rect">
-            <a:avLst/>
-          </a:prstGeom>
-          <a:noFill/>
-          <a:ln/>
-        </p:spPr>
-        <p:txBody>
-          <a:bodyPr wrap="square" lIns="25400" tIns="25400" rIns="25400" bIns="25400" rtlCol="0" anchor="t">
-            <a:normAutofit/>
-          </a:bodyPr>
-          <a:lstStyle/>
-          <a:p>
-            <a:pPr algn="l" indent="0" marL="0">
-              <a:buNone/>
-            </a:pPr>
-            <a:r>
-              <a:rPr lang="en-US" sz="1650" dirty="0">
-                <a:solidFill>
-                  <a:srgbClr val="6B655C"/>
-                </a:solidFill>
-                <a:latin typeface="Space Grotesk" pitchFamily="34" charset="0"/>
-                <a:ea typeface="Space Grotesk" pitchFamily="34" charset="-122"/>
-                <a:cs typeface="Space Grotesk" pitchFamily="34" charset="-120"/>
-              </a:rPr>
-              <a:t>Bulk UPDATE (write)</a:t>
-            </a:r>
-            <a:endParaRPr lang="en-US" sz="1650" dirty="0"/>
-          </a:p>
-        </p:txBody>
-      </p:sp>
-      <p:sp>
-        <p:nvSpPr>
-          <p:cNvPr id="61" name="Shape 59"/>
-          <p:cNvSpPr/>
-          <p:nvPr/>
-        </p:nvSpPr>
-        <p:spPr>
-          <a:xfrm>
-            <a:off x="7411889" y="7561608"/>
-            <a:ext cx="17390" cy="438015"/>
-          </a:xfrm>
-          <a:prstGeom prst="rect">
-            <a:avLst/>
-          </a:prstGeom>
-          <a:solidFill>
-            <a:srgbClr val="1A2430"/>
-          </a:solidFill>
-          <a:ln/>
-        </p:spPr>
-      </p:sp>
-      <p:sp>
-        <p:nvSpPr>
-          <p:cNvPr id="62" name="Shape 60"/>
-          <p:cNvSpPr/>
-          <p:nvPr/>
-        </p:nvSpPr>
-        <p:spPr>
-          <a:xfrm>
-            <a:off x="7429280" y="7637690"/>
-            <a:ext cx="704846" cy="285715"/>
-          </a:xfrm>
-          <a:prstGeom prst="rect">
-            <a:avLst/>
-          </a:prstGeom>
-          <a:solidFill>
-            <a:srgbClr val="1E7A52"/>
-          </a:solidFill>
-          <a:ln/>
-        </p:spPr>
-      </p:sp>
-      <p:sp>
-        <p:nvSpPr>
-          <p:cNvPr id="63" name="Text 61"/>
-          <p:cNvSpPr/>
-          <p:nvPr/>
-        </p:nvSpPr>
-        <p:spPr>
-          <a:xfrm>
-            <a:off x="10860144" y="7561608"/>
-            <a:ext cx="6475430" cy="476115"/>
-          </a:xfrm>
-          <a:prstGeom prst="rect">
-            <a:avLst/>
-          </a:prstGeom>
-          <a:noFill/>
-          <a:ln/>
-        </p:spPr>
-        <p:txBody>
-          <a:bodyPr wrap="square" lIns="25400" tIns="25400" rIns="25400" bIns="25400" rtlCol="0" anchor="ctr">
-            <a:normAutofit/>
-          </a:bodyPr>
-          <a:lstStyle/>
-          <a:p>
-            <a:pPr algn="r" indent="0" marL="0">
-              <a:buNone/>
-            </a:pPr>
-            <a:r>
-              <a:rPr lang="en-US" sz="1725" b="1" dirty="0">
-                <a:solidFill>
-                  <a:srgbClr val="1E7A52"/>
-                </a:solidFill>
-                <a:latin typeface="IBM Plex Mono" pitchFamily="34" charset="0"/>
-                <a:ea typeface="IBM Plex Mono" pitchFamily="34" charset="-122"/>
-                <a:cs typeface="IBM Plex Mono" pitchFamily="34" charset="-120"/>
-              </a:rPr>
-              <a:t>2.44×*</a:t>
-            </a:r>
-            <a:endParaRPr lang="en-US" sz="1725" dirty="0"/>
-          </a:p>
-        </p:txBody>
-      </p:sp>
-      <p:sp>
-        <p:nvSpPr>
-          <p:cNvPr id="64" name="Text 62"/>
-          <p:cNvSpPr/>
-          <p:nvPr/>
-        </p:nvSpPr>
-        <p:spPr>
-          <a:xfrm>
-            <a:off x="952385" y="7999623"/>
-            <a:ext cx="628610" cy="325038"/>
-          </a:xfrm>
-          <a:prstGeom prst="rect">
-            <a:avLst/>
-          </a:prstGeom>
-          <a:noFill/>
-          <a:ln/>
-        </p:spPr>
-        <p:txBody>
-          <a:bodyPr wrap="square" lIns="25400" tIns="25400" rIns="25400" bIns="25400" rtlCol="0" anchor="t">
-            <a:normAutofit/>
-          </a:bodyPr>
-          <a:lstStyle/>
-          <a:p>
-            <a:pPr algn="l" indent="0" marL="0">
-              <a:buNone/>
-            </a:pPr>
-            <a:r>
-              <a:rPr lang="en-US" sz="1725" b="1" dirty="0">
-                <a:solidFill>
-                  <a:srgbClr val="1A2430"/>
-                </a:solidFill>
-                <a:latin typeface="IBM Plex Mono" pitchFamily="34" charset="0"/>
-                <a:ea typeface="IBM Plex Mono" pitchFamily="34" charset="-122"/>
-                <a:cs typeface="IBM Plex Mono" pitchFamily="34" charset="-120"/>
-              </a:rPr>
-              <a:t>Q12</a:t>
-            </a:r>
-            <a:endParaRPr lang="en-US" sz="1725" dirty="0"/>
-          </a:p>
-        </p:txBody>
-      </p:sp>
-      <p:sp>
-        <p:nvSpPr>
-          <p:cNvPr id="65" name="Text 63"/>
-          <p:cNvSpPr/>
-          <p:nvPr/>
-        </p:nvSpPr>
-        <p:spPr>
-          <a:xfrm>
-            <a:off x="1638074" y="8017014"/>
-            <a:ext cx="2304920" cy="307648"/>
-          </a:xfrm>
-          <a:prstGeom prst="rect">
-            <a:avLst/>
-          </a:prstGeom>
-          <a:noFill/>
-          <a:ln/>
-        </p:spPr>
-        <p:txBody>
-          <a:bodyPr wrap="square" lIns="25400" tIns="25400" rIns="25400" bIns="25400" rtlCol="0" anchor="t">
-            <a:normAutofit/>
-          </a:bodyPr>
-          <a:lstStyle/>
-          <a:p>
-            <a:pPr algn="l" indent="0" marL="0">
-              <a:buNone/>
-            </a:pPr>
-            <a:r>
-              <a:rPr lang="en-US" sz="1650" dirty="0">
-                <a:solidFill>
-                  <a:srgbClr val="6B655C"/>
-                </a:solidFill>
-                <a:latin typeface="Space Grotesk" pitchFamily="34" charset="0"/>
-                <a:ea typeface="Space Grotesk" pitchFamily="34" charset="-122"/>
-                <a:cs typeface="Space Grotesk" pitchFamily="34" charset="-120"/>
-              </a:rPr>
-              <a:t>Schema evolution (write)</a:t>
-            </a:r>
-            <a:endParaRPr lang="en-US" sz="1650" dirty="0"/>
-          </a:p>
-        </p:txBody>
-      </p:sp>
-      <p:sp>
-        <p:nvSpPr>
-          <p:cNvPr id="66" name="Shape 64"/>
-          <p:cNvSpPr/>
-          <p:nvPr/>
-        </p:nvSpPr>
-        <p:spPr>
-          <a:xfrm>
-            <a:off x="7411889" y="7999623"/>
-            <a:ext cx="17390" cy="438015"/>
-          </a:xfrm>
-          <a:prstGeom prst="rect">
-            <a:avLst/>
-          </a:prstGeom>
-          <a:solidFill>
-            <a:srgbClr val="1A2430"/>
-          </a:solidFill>
-          <a:ln/>
-        </p:spPr>
-      </p:sp>
-      <p:sp>
-        <p:nvSpPr>
-          <p:cNvPr id="67" name="Shape 65"/>
-          <p:cNvSpPr/>
-          <p:nvPr/>
-        </p:nvSpPr>
-        <p:spPr>
-          <a:xfrm>
-            <a:off x="7429280" y="8075705"/>
-            <a:ext cx="2066851" cy="285715"/>
-          </a:xfrm>
-          <a:prstGeom prst="rect">
-            <a:avLst/>
-          </a:prstGeom>
-          <a:solidFill>
-            <a:srgbClr val="1E7A52"/>
-          </a:solidFill>
-          <a:ln/>
-        </p:spPr>
-      </p:sp>
-      <p:sp>
-        <p:nvSpPr>
-          <p:cNvPr id="68" name="Text 66"/>
-          <p:cNvSpPr/>
-          <p:nvPr/>
-        </p:nvSpPr>
-        <p:spPr>
-          <a:xfrm>
-            <a:off x="10860144" y="7999623"/>
-            <a:ext cx="6475430" cy="476115"/>
-          </a:xfrm>
-          <a:prstGeom prst="rect">
-            <a:avLst/>
-          </a:prstGeom>
-          <a:noFill/>
-          <a:ln/>
-        </p:spPr>
-        <p:txBody>
-          <a:bodyPr wrap="square" lIns="25400" tIns="25400" rIns="25400" bIns="25400" rtlCol="0" anchor="ctr">
-            <a:normAutofit/>
-          </a:bodyPr>
-          <a:lstStyle/>
-          <a:p>
-            <a:pPr algn="r" indent="0" marL="0">
-              <a:buNone/>
-            </a:pPr>
-            <a:r>
-              <a:rPr lang="en-US" sz="1725" b="1" dirty="0">
-                <a:solidFill>
-                  <a:srgbClr val="1E7A52"/>
-                </a:solidFill>
-                <a:latin typeface="IBM Plex Mono" pitchFamily="34" charset="0"/>
-                <a:ea typeface="IBM Plex Mono" pitchFamily="34" charset="-122"/>
-                <a:cs typeface="IBM Plex Mono" pitchFamily="34" charset="-120"/>
-              </a:rPr>
-              <a:t>13.70×*</a:t>
-            </a:r>
-            <a:endParaRPr lang="en-US" sz="1725" dirty="0"/>
-          </a:p>
-        </p:txBody>
-      </p:sp>
-      <p:sp>
-        <p:nvSpPr>
-          <p:cNvPr id="69" name="Text 67"/>
-          <p:cNvSpPr/>
-          <p:nvPr/>
-        </p:nvSpPr>
-        <p:spPr>
-          <a:xfrm>
-            <a:off x="952385" y="8818593"/>
-            <a:ext cx="2341086" cy="316343"/>
-          </a:xfrm>
-          <a:prstGeom prst="rect">
-            <a:avLst/>
-          </a:prstGeom>
-          <a:noFill/>
-          <a:ln/>
-        </p:spPr>
-        <p:txBody>
-          <a:bodyPr wrap="square" lIns="25400" tIns="25400" rIns="25400" bIns="25400" rtlCol="0" anchor="t">
-            <a:normAutofit/>
-          </a:bodyPr>
-          <a:lstStyle/>
-          <a:p>
-            <a:pPr algn="l" indent="0" marL="0">
-              <a:buNone/>
-            </a:pPr>
-            <a:r>
-              <a:rPr lang="en-US" sz="1725" dirty="0">
-                <a:solidFill>
-                  <a:srgbClr val="6B655C"/>
-                </a:solidFill>
-                <a:latin typeface="Space Grotesk" pitchFamily="34" charset="0"/>
-                <a:ea typeface="Space Grotesk" pitchFamily="34" charset="-122"/>
-                <a:cs typeface="Space Grotesk" pitchFamily="34" charset="-120"/>
-              </a:rPr>
-              <a:t>Postgres wins (4)</a:t>
-            </a:r>
-            <a:endParaRPr lang="en-US" sz="1725" dirty="0"/>
-          </a:p>
-        </p:txBody>
-      </p:sp>
-      <p:sp>
-        <p:nvSpPr>
-          <p:cNvPr id="70" name="Text 68"/>
-          <p:cNvSpPr/>
-          <p:nvPr/>
-        </p:nvSpPr>
-        <p:spPr>
-          <a:xfrm>
-            <a:off x="3556837" y="8818593"/>
-            <a:ext cx="1974045" cy="316343"/>
-          </a:xfrm>
-          <a:prstGeom prst="rect">
-            <a:avLst/>
-          </a:prstGeom>
-          <a:noFill/>
-          <a:ln/>
-        </p:spPr>
-        <p:txBody>
-          <a:bodyPr wrap="square" lIns="25400" tIns="25400" rIns="25400" bIns="25400" rtlCol="0" anchor="t">
-            <a:normAutofit/>
-          </a:bodyPr>
-          <a:lstStyle/>
-          <a:p>
-            <a:pPr algn="l" indent="0" marL="0">
-              <a:buNone/>
-            </a:pPr>
-            <a:r>
-              <a:rPr lang="en-US" sz="1725" dirty="0">
-                <a:solidFill>
-                  <a:srgbClr val="6B655C"/>
-                </a:solidFill>
-                <a:latin typeface="Space Grotesk" pitchFamily="34" charset="0"/>
-                <a:ea typeface="Space Grotesk" pitchFamily="34" charset="-122"/>
-                <a:cs typeface="Space Grotesk" pitchFamily="34" charset="-120"/>
-              </a:rPr>
-              <a:t>Neo4j wins (8)</a:t>
-            </a:r>
-            <a:endParaRPr lang="en-US" sz="1725" dirty="0"/>
-          </a:p>
-        </p:txBody>
-      </p:sp>
-      <p:sp>
-        <p:nvSpPr>
-          <p:cNvPr id="71" name="Text 69"/>
-          <p:cNvSpPr/>
-          <p:nvPr/>
-        </p:nvSpPr>
-        <p:spPr>
-          <a:xfrm>
-            <a:off x="5827616" y="8827288"/>
-            <a:ext cx="10031477" cy="298953"/>
-          </a:xfrm>
-          <a:prstGeom prst="rect">
-            <a:avLst/>
-          </a:prstGeom>
-          <a:noFill/>
-          <a:ln/>
-        </p:spPr>
-        <p:txBody>
-          <a:bodyPr wrap="square" lIns="25400" tIns="25400" rIns="25400" bIns="25400" rtlCol="0" anchor="t">
-            <a:normAutofit/>
-          </a:bodyPr>
-          <a:lstStyle/>
-          <a:p>
-            <a:pPr algn="l" indent="0" marL="0">
-              <a:buNone/>
-            </a:pPr>
-            <a:r>
-              <a:rPr lang="en-US" sz="1575" dirty="0">
-                <a:solidFill>
-                  <a:srgbClr val="6B655C"/>
-                </a:solidFill>
-                <a:latin typeface="IBM Plex Mono" pitchFamily="34" charset="0"/>
-                <a:ea typeface="IBM Plex Mono" pitchFamily="34" charset="-122"/>
-                <a:cs typeface="IBM Plex Mono" pitchFamily="34" charset="-120"/>
-              </a:rPr>
-              <a:t>* 11/12 significant · Mann-Whitney U, p &lt; 0.05 · all read results equivalent</a:t>
+              <a:t>* 11/12 significant · Mann-Whitney U, p &lt; 0.05, Holm-corrected · all results equivalent (multiset)</a:t>
             </a:r>
             <a:endParaRPr lang="en-US" sz="1575" dirty="0"/>
           </a:p>
@@ -5275,7 +5269,7 @@
                 <a:ea typeface="Space Grotesk" pitchFamily="34" charset="-122"/>
                 <a:cs typeface="Space Grotesk" pitchFamily="34" charset="-120"/>
               </a:rPr>
-              <a:t>89×</a:t>
+              <a:t>57×</a:t>
             </a:r>
             <a:endParaRPr lang="en-US" sz="30000" dirty="0"/>
           </a:p>
@@ -5398,7 +5392,7 @@
                 <a:ea typeface="IBM Plex Mono" pitchFamily="34" charset="-122"/>
                 <a:cs typeface="IBM Plex Mono" pitchFamily="34" charset="-120"/>
               </a:rPr>
-              <a:t>712 ms</a:t>
+              <a:t>671 ms</a:t>
             </a:r>
             <a:endParaRPr lang="en-US" sz="4800" dirty="0"/>
           </a:p>
@@ -5521,7 +5515,7 @@
                 <a:ea typeface="IBM Plex Mono" pitchFamily="34" charset="-122"/>
                 <a:cs typeface="IBM Plex Mono" pitchFamily="34" charset="-120"/>
               </a:rPr>
-              <a:t>8 ms</a:t>
+              <a:t>12 ms</a:t>
             </a:r>
             <a:endParaRPr lang="en-US" sz="4800" dirty="0"/>
           </a:p>
@@ -5562,7 +5556,7 @@
                 <a:ea typeface="IBM Plex Mono" pitchFamily="34" charset="-122"/>
                 <a:cs typeface="IBM Plex Mono" pitchFamily="34" charset="-120"/>
               </a:rPr>
-              <a:t>built-in shortestPath()</a:t>
+              <a:t>SHORTEST 1 path pattern</a:t>
             </a:r>
             <a:endParaRPr lang="en-US" sz="1650" dirty="0"/>
           </a:p>
@@ -5761,7 +5755,7 @@
                 <a:ea typeface="Space Grotesk" pitchFamily="34" charset="-122"/>
                 <a:cs typeface="Space Grotesk" pitchFamily="34" charset="-120"/>
               </a:rPr>
-              <a:t>21 lines of recursive CTE vs 3 lines of Cypher — same answer</a:t>
+              <a:t>21 lines of recursive CTE vs 5 lines of Cypher — same answer, same semantics</a:t>
             </a:r>
             <a:endParaRPr lang="en-US" sz="4350" dirty="0"/>
           </a:p>
@@ -5866,860 +5860,591 @@
                 <a:ea typeface="IBM Plex Mono" pitchFamily="34" charset="-122"/>
                 <a:cs typeface="IBM Plex Mono" pitchFamily="34" charset="-120"/>
               </a:rPr>
-              <a:t>WITH RECURSIVE</a:t>
+              <a:t>WITH RECURSIVE bfs (player_api_id, distance) AS (</a:t>
             </a:r>
             <a:endParaRPr lang="en-US" sz="1388" dirty="0"/>
           </a:p>
           <a:p>
-            <a:pPr algn="l" indent="0" marL="0">
-              <a:lnSpc>
-                <a:spcPct val="142000"/>
-              </a:lnSpc>
-              <a:buNone/>
-            </a:pPr>
-            <a:r>
-              <a:rPr lang="en-US" sz="1388" dirty="0">
+            <a:r>
+              <a:rPr sz="1388">
                 <a:solidFill>
                   <a:srgbClr val="B8C4D2"/>
+                </a:solidFill>
+                <a:latin typeface="IBM Plex Mono"/>
+              </a:rPr>
+              <a:t>    SELECT src, 0 FROM endpoints</a:t>
+            </a:r>
+          </a:p>
+          <a:p>
+            <a:r>
+              <a:rPr sz="1388">
+                <a:solidFill>
+                  <a:srgbClr val="B8C4D2"/>
+                </a:solidFill>
+                <a:latin typeface="IBM Plex Mono"/>
+              </a:rPr>
+              <a:t>    UNION</a:t>
+            </a:r>
+          </a:p>
+          <a:p>
+            <a:r>
+              <a:rPr sz="1388">
+                <a:solidFill>
+                  <a:srgbClr val="B8C4D2"/>
+                </a:solidFill>
+                <a:latin typeface="IBM Plex Mono"/>
+              </a:rPr>
+              <a:t>    SELECT pf2.player_api_id, b.distance + 1</a:t>
+            </a:r>
+          </a:p>
+          <a:p>
+            <a:r>
+              <a:rPr sz="1388">
+                <a:solidFill>
+                  <a:srgbClr val="B8C4D2"/>
+                </a:solidFill>
+                <a:latin typeface="IBM Plex Mono"/>
+              </a:rPr>
+              <a:t>    FROM   bfs b</a:t>
+            </a:r>
+          </a:p>
+          <a:p>
+            <a:r>
+              <a:rPr sz="1388">
+                <a:solidFill>
+                  <a:srgbClr val="B8C4D2"/>
+                </a:solidFill>
+                <a:latin typeface="IBM Plex Mono"/>
+              </a:rPr>
+              <a:t>    JOIN   soccer.mv_played_for pf1</a:t>
+            </a:r>
+          </a:p>
+          <a:p>
+            <a:r>
+              <a:rPr sz="1388">
+                <a:solidFill>
+                  <a:srgbClr val="B8C4D2"/>
+                </a:solidFill>
+                <a:latin typeface="IBM Plex Mono"/>
+              </a:rPr>
+              <a:t>           ON pf1.player_api_id = b.player_api_id</a:t>
+            </a:r>
+          </a:p>
+          <a:p>
+            <a:r>
+              <a:rPr sz="1388">
+                <a:solidFill>
+                  <a:srgbClr val="B8C4D2"/>
+                </a:solidFill>
+                <a:latin typeface="IBM Plex Mono"/>
+              </a:rPr>
+              <a:t>    JOIN   soccer.mv_played_for pf2</a:t>
+            </a:r>
+          </a:p>
+          <a:p>
+            <a:r>
+              <a:rPr sz="1388">
+                <a:solidFill>
+                  <a:srgbClr val="B8C4D2"/>
+                </a:solidFill>
+                <a:latin typeface="IBM Plex Mono"/>
+              </a:rPr>
+              <a:t>           ON pf2.team_api_id = pf1.team_api_id</a:t>
+            </a:r>
+          </a:p>
+          <a:p>
+            <a:r>
+              <a:rPr sz="1388">
+                <a:solidFill>
+                  <a:srgbClr val="B8C4D2"/>
+                </a:solidFill>
+                <a:latin typeface="IBM Plex Mono"/>
+              </a:rPr>
+              <a:t>          AND pf2.season      = pf1.season</a:t>
+            </a:r>
+          </a:p>
+          <a:p>
+            <a:r>
+              <a:rPr sz="1388">
+                <a:solidFill>
+                  <a:srgbClr val="B8C4D2"/>
+                </a:solidFill>
+                <a:latin typeface="IBM Plex Mono"/>
+              </a:rPr>
+              <a:t>          AND pf2.player_api_id &lt;&gt; b.player_api_id</a:t>
+            </a:r>
+          </a:p>
+          <a:p>
+            <a:r>
+              <a:rPr sz="1388">
+                <a:solidFill>
+                  <a:srgbClr val="B8C4D2"/>
+                </a:solidFill>
+                <a:latin typeface="IBM Plex Mono"/>
+              </a:rPr>
+              <a:t>    WHERE  b.distance &lt; 6</a:t>
+            </a:r>
+          </a:p>
+          <a:p>
+            <a:r>
+              <a:rPr sz="1388">
+                <a:solidFill>
+                  <a:srgbClr val="B8C4D2"/>
+                </a:solidFill>
+                <a:latin typeface="IBM Plex Mono"/>
+              </a:rPr>
+              <a:t>)</a:t>
+            </a:r>
+          </a:p>
+          <a:p>
+            <a:r>
+              <a:rPr sz="1388">
+                <a:solidFill>
+                  <a:srgbClr val="B8C4D2"/>
+                </a:solidFill>
+                <a:latin typeface="IBM Plex Mono"/>
+              </a:rPr>
+              <a:t>SELECT MIN(distance) FROM bfs</a:t>
+            </a:r>
+          </a:p>
+          <a:p>
+            <a:r>
+              <a:rPr sz="1388">
+                <a:solidFill>
+                  <a:srgbClr val="B8C4D2"/>
+                </a:solidFill>
+                <a:latin typeface="IBM Plex Mono"/>
+              </a:rPr>
+              <a:t>WHERE  player_api_id = dst;</a:t>
+            </a:r>
+          </a:p>
+        </p:txBody>
+      </p:sp>
+      <p:sp>
+        <p:nvSpPr>
+          <p:cNvPr id="7" name="Text 5"/>
+          <p:cNvSpPr/>
+          <p:nvPr/>
+        </p:nvSpPr>
+        <p:spPr>
+          <a:xfrm>
+            <a:off x="7677158" y="3763618"/>
+            <a:ext cx="2933644" cy="751098"/>
+          </a:xfrm>
+          <a:prstGeom prst="rect">
+            <a:avLst/>
+          </a:prstGeom>
+          <a:noFill/>
+          <a:ln/>
+        </p:spPr>
+        <p:txBody>
+          <a:bodyPr wrap="square" lIns="25400" tIns="25400" rIns="25400" bIns="25400" rtlCol="0" anchor="t">
+            <a:normAutofit/>
+          </a:bodyPr>
+          <a:lstStyle/>
+          <a:p>
+            <a:pPr algn="ctr" indent="0" marL="0">
+              <a:buNone/>
+            </a:pPr>
+            <a:r>
+              <a:rPr lang="en-US" sz="4350" b="1" dirty="0">
+                <a:solidFill>
+                  <a:srgbClr val="1E7A52"/>
+                </a:solidFill>
+                <a:latin typeface="Space Grotesk" pitchFamily="34" charset="0"/>
+                <a:ea typeface="Space Grotesk" pitchFamily="34" charset="-122"/>
+                <a:cs typeface="Space Grotesk" pitchFamily="34" charset="-120"/>
+              </a:rPr>
+              <a:t>21 → 5</a:t>
+            </a:r>
+            <a:endParaRPr lang="en-US" sz="4350" dirty="0"/>
+          </a:p>
+        </p:txBody>
+      </p:sp>
+      <p:sp>
+        <p:nvSpPr>
+          <p:cNvPr id="8" name="Text 6"/>
+          <p:cNvSpPr/>
+          <p:nvPr/>
+        </p:nvSpPr>
+        <p:spPr>
+          <a:xfrm>
+            <a:off x="7677158" y="4514656"/>
+            <a:ext cx="2933644" cy="298953"/>
+          </a:xfrm>
+          <a:prstGeom prst="rect">
+            <a:avLst/>
+          </a:prstGeom>
+          <a:noFill/>
+          <a:ln/>
+        </p:spPr>
+        <p:txBody>
+          <a:bodyPr wrap="square" lIns="25400" tIns="25400" rIns="25400" bIns="25400" rtlCol="0" anchor="t">
+            <a:normAutofit/>
+          </a:bodyPr>
+          <a:lstStyle/>
+          <a:p>
+            <a:pPr algn="ctr" indent="0" marL="0">
+              <a:buNone/>
+            </a:pPr>
+            <a:r>
+              <a:rPr lang="en-US" sz="1575" dirty="0">
+                <a:solidFill>
+                  <a:srgbClr val="6B655C"/>
                 </a:solidFill>
                 <a:latin typeface="IBM Plex Mono" pitchFamily="34" charset="0"/>
                 <a:ea typeface="IBM Plex Mono" pitchFamily="34" charset="-122"/>
                 <a:cs typeface="IBM Plex Mono" pitchFamily="34" charset="-120"/>
               </a:rPr>
-              <a:t>played_for AS (</a:t>
-            </a:r>
-            <a:endParaRPr lang="en-US" sz="1388" dirty="0"/>
-          </a:p>
-          <a:p>
-            <a:pPr algn="l" indent="0" marL="0">
-              <a:lnSpc>
-                <a:spcPct val="142000"/>
-              </a:lnSpc>
-              <a:buNone/>
-            </a:pPr>
-            <a:r>
-              <a:rPr lang="en-US" sz="1388" dirty="0">
-                <a:solidFill>
-                  <a:srgbClr val="B8C4D2"/>
+              <a:t>lines of code</a:t>
+            </a:r>
+            <a:endParaRPr lang="en-US" sz="1575" dirty="0"/>
+          </a:p>
+        </p:txBody>
+      </p:sp>
+      <p:sp>
+        <p:nvSpPr>
+          <p:cNvPr id="9" name="Text 7"/>
+          <p:cNvSpPr/>
+          <p:nvPr/>
+        </p:nvSpPr>
+        <p:spPr>
+          <a:xfrm>
+            <a:off x="7677158" y="5118286"/>
+            <a:ext cx="2933644" cy="751098"/>
+          </a:xfrm>
+          <a:prstGeom prst="rect">
+            <a:avLst/>
+          </a:prstGeom>
+          <a:noFill/>
+          <a:ln/>
+        </p:spPr>
+        <p:txBody>
+          <a:bodyPr wrap="square" lIns="25400" tIns="25400" rIns="25400" bIns="25400" rtlCol="0" anchor="t">
+            <a:normAutofit/>
+          </a:bodyPr>
+          <a:lstStyle/>
+          <a:p>
+            <a:pPr algn="ctr" indent="0" marL="0">
+              <a:buNone/>
+            </a:pPr>
+            <a:r>
+              <a:rPr lang="en-US" sz="4350" b="1" dirty="0">
+                <a:solidFill>
+                  <a:srgbClr val="1E7A52"/>
+                </a:solidFill>
+                <a:latin typeface="Space Grotesk" pitchFamily="34" charset="0"/>
+                <a:ea typeface="Space Grotesk" pitchFamily="34" charset="-122"/>
+                <a:cs typeface="Space Grotesk" pitchFamily="34" charset="-120"/>
+              </a:rPr>
+              <a:t>26 → 5</a:t>
+            </a:r>
+            <a:endParaRPr lang="en-US" sz="4350" dirty="0"/>
+          </a:p>
+        </p:txBody>
+      </p:sp>
+      <p:sp>
+        <p:nvSpPr>
+          <p:cNvPr id="10" name="Text 8"/>
+          <p:cNvSpPr/>
+          <p:nvPr/>
+        </p:nvSpPr>
+        <p:spPr>
+          <a:xfrm>
+            <a:off x="7677158" y="5869325"/>
+            <a:ext cx="2933644" cy="298953"/>
+          </a:xfrm>
+          <a:prstGeom prst="rect">
+            <a:avLst/>
+          </a:prstGeom>
+          <a:noFill/>
+          <a:ln/>
+        </p:spPr>
+        <p:txBody>
+          <a:bodyPr wrap="square" lIns="25400" tIns="25400" rIns="25400" bIns="25400" rtlCol="0" anchor="t">
+            <a:normAutofit/>
+          </a:bodyPr>
+          <a:lstStyle/>
+          <a:p>
+            <a:pPr algn="ctr" indent="0" marL="0">
+              <a:buNone/>
+            </a:pPr>
+            <a:r>
+              <a:rPr lang="en-US" sz="1575" dirty="0">
+                <a:solidFill>
+                  <a:srgbClr val="6B655C"/>
                 </a:solidFill>
                 <a:latin typeface="IBM Plex Mono" pitchFamily="34" charset="0"/>
                 <a:ea typeface="IBM Plex Mono" pitchFamily="34" charset="-122"/>
                 <a:cs typeface="IBM Plex Mono" pitchFamily="34" charset="-120"/>
               </a:rPr>
-              <a:t>  SELECT DISTINCT l.player_api_id,</a:t>
-            </a:r>
-            <a:endParaRPr lang="en-US" sz="1388" dirty="0"/>
-          </a:p>
-          <a:p>
-            <a:pPr algn="l" indent="0" marL="0">
-              <a:lnSpc>
-                <a:spcPct val="142000"/>
-              </a:lnSpc>
-              <a:buNone/>
-            </a:pPr>
-            <a:r>
-              <a:rPr lang="en-US" sz="1388" dirty="0">
-                <a:solidFill>
-                  <a:srgbClr val="B8C4D2"/>
+              <a:t>logical operators</a:t>
+            </a:r>
+            <a:endParaRPr lang="en-US" sz="1575" dirty="0"/>
+          </a:p>
+        </p:txBody>
+      </p:sp>
+      <p:sp>
+        <p:nvSpPr>
+          <p:cNvPr id="11" name="Text 9"/>
+          <p:cNvSpPr/>
+          <p:nvPr/>
+        </p:nvSpPr>
+        <p:spPr>
+          <a:xfrm>
+            <a:off x="7677158" y="6472955"/>
+            <a:ext cx="2933644" cy="751098"/>
+          </a:xfrm>
+          <a:prstGeom prst="rect">
+            <a:avLst/>
+          </a:prstGeom>
+          <a:noFill/>
+          <a:ln/>
+        </p:spPr>
+        <p:txBody>
+          <a:bodyPr wrap="square" lIns="25400" tIns="25400" rIns="25400" bIns="25400" rtlCol="0" anchor="t">
+            <a:normAutofit/>
+          </a:bodyPr>
+          <a:lstStyle/>
+          <a:p>
+            <a:pPr algn="ctr" indent="0" marL="0">
+              <a:buNone/>
+            </a:pPr>
+            <a:r>
+              <a:rPr lang="en-US" sz="4350" b="1" dirty="0">
+                <a:solidFill>
+                  <a:srgbClr val="1E7A52"/>
+                </a:solidFill>
+                <a:latin typeface="Space Grotesk" pitchFamily="34" charset="0"/>
+                <a:ea typeface="Space Grotesk" pitchFamily="34" charset="-122"/>
+                <a:cs typeface="Space Grotesk" pitchFamily="34" charset="-120"/>
+              </a:rPr>
+              <a:t>671 → 12</a:t>
+            </a:r>
+            <a:endParaRPr lang="en-US" sz="4350" dirty="0"/>
+          </a:p>
+        </p:txBody>
+      </p:sp>
+      <p:sp>
+        <p:nvSpPr>
+          <p:cNvPr id="12" name="Text 10"/>
+          <p:cNvSpPr/>
+          <p:nvPr/>
+        </p:nvSpPr>
+        <p:spPr>
+          <a:xfrm>
+            <a:off x="7677158" y="7223994"/>
+            <a:ext cx="2933644" cy="298953"/>
+          </a:xfrm>
+          <a:prstGeom prst="rect">
+            <a:avLst/>
+          </a:prstGeom>
+          <a:noFill/>
+          <a:ln/>
+        </p:spPr>
+        <p:txBody>
+          <a:bodyPr wrap="square" lIns="25400" tIns="25400" rIns="25400" bIns="25400" rtlCol="0" anchor="t">
+            <a:normAutofit/>
+          </a:bodyPr>
+          <a:lstStyle/>
+          <a:p>
+            <a:pPr algn="ctr" indent="0" marL="0">
+              <a:buNone/>
+            </a:pPr>
+            <a:r>
+              <a:rPr lang="en-US" sz="1575" dirty="0">
+                <a:solidFill>
+                  <a:srgbClr val="6B655C"/>
                 </a:solidFill>
                 <a:latin typeface="IBM Plex Mono" pitchFamily="34" charset="0"/>
                 <a:ea typeface="IBM Plex Mono" pitchFamily="34" charset="-122"/>
                 <a:cs typeface="IBM Plex Mono" pitchFamily="34" charset="-120"/>
               </a:rPr>
-              <a:t>    CASE WHEN l.side='home'</a:t>
-            </a:r>
-            <a:endParaRPr lang="en-US" sz="1388" dirty="0"/>
-          </a:p>
-          <a:p>
-            <a:pPr algn="l" indent="0" marL="0">
-              <a:lnSpc>
-                <a:spcPct val="142000"/>
-              </a:lnSpc>
-              <a:buNone/>
-            </a:pPr>
-            <a:r>
-              <a:rPr lang="en-US" sz="1388" dirty="0">
-                <a:solidFill>
-                  <a:srgbClr val="B8C4D2"/>
+              <a:t>milliseconds</a:t>
+            </a:r>
+            <a:endParaRPr lang="en-US" sz="1575" dirty="0"/>
+          </a:p>
+        </p:txBody>
+      </p:sp>
+      <p:sp>
+        <p:nvSpPr>
+          <p:cNvPr id="13" name="Shape 11"/>
+          <p:cNvSpPr/>
+          <p:nvPr/>
+        </p:nvSpPr>
+        <p:spPr>
+          <a:xfrm>
+            <a:off x="10858408" y="2208011"/>
+            <a:ext cx="6477167" cy="6832443"/>
+          </a:xfrm>
+          <a:prstGeom prst="rect">
+            <a:avLst/>
+          </a:prstGeom>
+          <a:solidFill>
+            <a:srgbClr val="16202C"/>
+          </a:solidFill>
+          <a:ln/>
+        </p:spPr>
+      </p:sp>
+      <p:sp>
+        <p:nvSpPr>
+          <p:cNvPr id="14" name="Text 12"/>
+          <p:cNvSpPr/>
+          <p:nvPr/>
+        </p:nvSpPr>
+        <p:spPr>
+          <a:xfrm>
+            <a:off x="11239362" y="2531767"/>
+            <a:ext cx="6286785" cy="298953"/>
+          </a:xfrm>
+          <a:prstGeom prst="rect">
+            <a:avLst/>
+          </a:prstGeom>
+          <a:noFill/>
+          <a:ln/>
+        </p:spPr>
+        <p:txBody>
+          <a:bodyPr wrap="square" lIns="25400" tIns="25400" rIns="25400" bIns="25400" rtlCol="0" anchor="t">
+            <a:normAutofit/>
+          </a:bodyPr>
+          <a:lstStyle/>
+          <a:p>
+            <a:pPr algn="l" indent="0" marL="0">
+              <a:buNone/>
+            </a:pPr>
+            <a:r>
+              <a:rPr lang="en-US" sz="1575" spc="158" kern="0" dirty="0">
+                <a:solidFill>
+                  <a:srgbClr val="6FC79B"/>
                 </a:solidFill>
                 <a:latin typeface="IBM Plex Mono" pitchFamily="34" charset="0"/>
                 <a:ea typeface="IBM Plex Mono" pitchFamily="34" charset="-122"/>
                 <a:cs typeface="IBM Plex Mono" pitchFamily="34" charset="-120"/>
               </a:rPr>
-              <a:t>      THEN m.home_team_api_id</a:t>
-            </a:r>
-            <a:endParaRPr lang="en-US" sz="1388" dirty="0"/>
-          </a:p>
+              <a:t>NEO4J — SHORTEST 1 PATH PATTERN (GQL)</a:t>
+            </a:r>
+            <a:endParaRPr lang="en-US" sz="1575" dirty="0"/>
+          </a:p>
+        </p:txBody>
+      </p:sp>
+      <p:sp>
+        <p:nvSpPr>
+          <p:cNvPr id="15" name="Text 13"/>
+          <p:cNvSpPr/>
+          <p:nvPr/>
+        </p:nvSpPr>
+        <p:spPr>
+          <a:xfrm>
+            <a:off x="11239362" y="4926179"/>
+            <a:ext cx="4944243" cy="1866244"/>
+          </a:xfrm>
+          <a:prstGeom prst="rect">
+            <a:avLst/>
+          </a:prstGeom>
+          <a:noFill/>
+          <a:ln/>
+        </p:spPr>
+        <p:txBody>
+          <a:bodyPr wrap="none" lIns="25400" tIns="25400" rIns="25400" bIns="25400" rtlCol="0" anchor="t">
+            <a:normAutofit/>
+          </a:bodyPr>
+          <a:lstStyle/>
           <a:p>
             <a:pPr algn="l" indent="0" marL="0">
               <a:lnSpc>
-                <a:spcPct val="142000"/>
+                <a:spcPct val="160000"/>
               </a:lnSpc>
               <a:buNone/>
             </a:pPr>
             <a:r>
-              <a:rPr lang="en-US" sz="1388" dirty="0">
-                <a:solidFill>
-                  <a:srgbClr val="B8C4D2"/>
+              <a:rPr lang="en-US" sz="2250" dirty="0">
+                <a:solidFill>
+                  <a:srgbClr val="D5E5DC"/>
                 </a:solidFill>
                 <a:latin typeface="IBM Plex Mono" pitchFamily="34" charset="0"/>
                 <a:ea typeface="IBM Plex Mono" pitchFamily="34" charset="-122"/>
                 <a:cs typeface="IBM Plex Mono" pitchFamily="34" charset="-120"/>
               </a:rPr>
-              <a:t>      ELSE m.away_team_api_id END t,</a:t>
-            </a:r>
-            <a:endParaRPr lang="en-US" sz="1388" dirty="0"/>
-          </a:p>
-          <a:p>
-            <a:pPr algn="l" indent="0" marL="0">
-              <a:lnSpc>
-                <a:spcPct val="142000"/>
-              </a:lnSpc>
-              <a:buNone/>
-            </a:pPr>
-            <a:r>
-              <a:rPr lang="en-US" sz="1388" dirty="0">
-                <a:solidFill>
-                  <a:srgbClr val="B8C4D2"/>
-                </a:solidFill>
-                <a:latin typeface="IBM Plex Mono" pitchFamily="34" charset="0"/>
-                <a:ea typeface="IBM Plex Mono" pitchFamily="34" charset="-122"/>
-                <a:cs typeface="IBM Plex Mono" pitchFamily="34" charset="-120"/>
-              </a:rPr>
-              <a:t>    m.season</a:t>
-            </a:r>
-            <a:endParaRPr lang="en-US" sz="1388" dirty="0"/>
-          </a:p>
-          <a:p>
-            <a:pPr algn="l" indent="0" marL="0">
-              <a:lnSpc>
-                <a:spcPct val="142000"/>
-              </a:lnSpc>
-              <a:buNone/>
-            </a:pPr>
-            <a:r>
-              <a:rPr lang="en-US" sz="1388" dirty="0">
-                <a:solidFill>
-                  <a:srgbClr val="B8C4D2"/>
-                </a:solidFill>
-                <a:latin typeface="IBM Plex Mono" pitchFamily="34" charset="0"/>
-                <a:ea typeface="IBM Plex Mono" pitchFamily="34" charset="-122"/>
-                <a:cs typeface="IBM Plex Mono" pitchFamily="34" charset="-120"/>
-              </a:rPr>
-              <a:t>  FROM match_lineup l</a:t>
-            </a:r>
-            <a:endParaRPr lang="en-US" sz="1388" dirty="0"/>
-          </a:p>
-          <a:p>
-            <a:pPr algn="l" indent="0" marL="0">
-              <a:lnSpc>
-                <a:spcPct val="142000"/>
-              </a:lnSpc>
-              <a:buNone/>
-            </a:pPr>
-            <a:r>
-              <a:rPr lang="en-US" sz="1388" dirty="0">
-                <a:solidFill>
-                  <a:srgbClr val="B8C4D2"/>
-                </a:solidFill>
-                <a:latin typeface="IBM Plex Mono" pitchFamily="34" charset="0"/>
-                <a:ea typeface="IBM Plex Mono" pitchFamily="34" charset="-122"/>
-                <a:cs typeface="IBM Plex Mono" pitchFamily="34" charset="-120"/>
-              </a:rPr>
-              <a:t>  JOIN match m USING (match_api_id)</a:t>
-            </a:r>
-            <a:endParaRPr lang="en-US" sz="1388" dirty="0"/>
-          </a:p>
-          <a:p>
-            <a:pPr algn="l" indent="0" marL="0">
-              <a:lnSpc>
-                <a:spcPct val="142000"/>
-              </a:lnSpc>
-              <a:buNone/>
-            </a:pPr>
-            <a:r>
-              <a:rPr lang="en-US" sz="1388" dirty="0">
-                <a:solidFill>
-                  <a:srgbClr val="B8C4D2"/>
-                </a:solidFill>
-                <a:latin typeface="IBM Plex Mono" pitchFamily="34" charset="0"/>
-                <a:ea typeface="IBM Plex Mono" pitchFamily="34" charset="-122"/>
-                <a:cs typeface="IBM Plex Mono" pitchFamily="34" charset="-120"/>
-              </a:rPr>
-              <a:t>),</a:t>
-            </a:r>
-            <a:endParaRPr lang="en-US" sz="1388" dirty="0"/>
-          </a:p>
-          <a:p>
-            <a:pPr algn="l" indent="0" marL="0">
-              <a:lnSpc>
-                <a:spcPct val="142000"/>
-              </a:lnSpc>
-              <a:buNone/>
-            </a:pPr>
-            <a:r>
-              <a:rPr lang="en-US" sz="1388" dirty="0">
-                <a:solidFill>
-                  <a:srgbClr val="B8C4D2"/>
-                </a:solidFill>
-                <a:latin typeface="IBM Plex Mono" pitchFamily="34" charset="0"/>
-                <a:ea typeface="IBM Plex Mono" pitchFamily="34" charset="-122"/>
-                <a:cs typeface="IBM Plex Mono" pitchFamily="34" charset="-120"/>
-              </a:rPr>
-              <a:t>bfs (player_api_id, distance) AS (</a:t>
-            </a:r>
-            <a:endParaRPr lang="en-US" sz="1388" dirty="0"/>
-          </a:p>
-          <a:p>
-            <a:pPr algn="l" indent="0" marL="0">
-              <a:lnSpc>
-                <a:spcPct val="142000"/>
-              </a:lnSpc>
-              <a:buNone/>
-            </a:pPr>
-            <a:r>
-              <a:rPr lang="en-US" sz="1388" dirty="0">
-                <a:solidFill>
-                  <a:srgbClr val="B8C4D2"/>
-                </a:solidFill>
-                <a:latin typeface="IBM Plex Mono" pitchFamily="34" charset="0"/>
-                <a:ea typeface="IBM Plex Mono" pitchFamily="34" charset="-122"/>
-                <a:cs typeface="IBM Plex Mono" pitchFamily="34" charset="-120"/>
-              </a:rPr>
-              <a:t>  SELECT src, 0 FROM endpoints</a:t>
-            </a:r>
-            <a:endParaRPr lang="en-US" sz="1388" dirty="0"/>
-          </a:p>
-          <a:p>
-            <a:pPr algn="l" indent="0" marL="0">
-              <a:lnSpc>
-                <a:spcPct val="142000"/>
-              </a:lnSpc>
-              <a:buNone/>
-            </a:pPr>
-            <a:r>
-              <a:rPr lang="en-US" sz="1388" dirty="0">
-                <a:solidFill>
-                  <a:srgbClr val="B8C4D2"/>
-                </a:solidFill>
-                <a:latin typeface="IBM Plex Mono" pitchFamily="34" charset="0"/>
-                <a:ea typeface="IBM Plex Mono" pitchFamily="34" charset="-122"/>
-                <a:cs typeface="IBM Plex Mono" pitchFamily="34" charset="-120"/>
-              </a:rPr>
-              <a:t>  UNION</a:t>
-            </a:r>
-            <a:endParaRPr lang="en-US" sz="1388" dirty="0"/>
-          </a:p>
-          <a:p>
-            <a:pPr algn="l" indent="0" marL="0">
-              <a:lnSpc>
-                <a:spcPct val="142000"/>
-              </a:lnSpc>
-              <a:buNone/>
-            </a:pPr>
-            <a:r>
-              <a:rPr lang="en-US" sz="1388" dirty="0">
-                <a:solidFill>
-                  <a:srgbClr val="B8C4D2"/>
-                </a:solidFill>
-                <a:latin typeface="IBM Plex Mono" pitchFamily="34" charset="0"/>
-                <a:ea typeface="IBM Plex Mono" pitchFamily="34" charset="-122"/>
-                <a:cs typeface="IBM Plex Mono" pitchFamily="34" charset="-120"/>
-              </a:rPr>
-              <a:t>  SELECT pf2.player_api_id, b.distance + 1</a:t>
-            </a:r>
-            <a:endParaRPr lang="en-US" sz="1388" dirty="0"/>
-          </a:p>
-          <a:p>
-            <a:pPr algn="l" indent="0" marL="0">
-              <a:lnSpc>
-                <a:spcPct val="142000"/>
-              </a:lnSpc>
-              <a:buNone/>
-            </a:pPr>
-            <a:r>
-              <a:rPr lang="en-US" sz="1388" dirty="0">
-                <a:solidFill>
-                  <a:srgbClr val="B8C4D2"/>
-                </a:solidFill>
-                <a:latin typeface="IBM Plex Mono" pitchFamily="34" charset="0"/>
-                <a:ea typeface="IBM Plex Mono" pitchFamily="34" charset="-122"/>
-                <a:cs typeface="IBM Plex Mono" pitchFamily="34" charset="-120"/>
-              </a:rPr>
-              <a:t>  FROM bfs b</a:t>
-            </a:r>
-            <a:endParaRPr lang="en-US" sz="1388" dirty="0"/>
-          </a:p>
-          <a:p>
-            <a:pPr algn="l" indent="0" marL="0">
-              <a:lnSpc>
-                <a:spcPct val="142000"/>
-              </a:lnSpc>
-              <a:buNone/>
-            </a:pPr>
-            <a:r>
-              <a:rPr lang="en-US" sz="1388" dirty="0">
-                <a:solidFill>
-                  <a:srgbClr val="B8C4D2"/>
-                </a:solidFill>
-                <a:latin typeface="IBM Plex Mono" pitchFamily="34" charset="0"/>
-                <a:ea typeface="IBM Plex Mono" pitchFamily="34" charset="-122"/>
-                <a:cs typeface="IBM Plex Mono" pitchFamily="34" charset="-120"/>
-              </a:rPr>
-              <a:t>  JOIN played_for pf1</a:t>
-            </a:r>
-            <a:endParaRPr lang="en-US" sz="1388" dirty="0"/>
-          </a:p>
-          <a:p>
-            <a:pPr algn="l" indent="0" marL="0">
-              <a:lnSpc>
-                <a:spcPct val="142000"/>
-              </a:lnSpc>
-              <a:buNone/>
-            </a:pPr>
-            <a:r>
-              <a:rPr lang="en-US" sz="1388" dirty="0">
-                <a:solidFill>
-                  <a:srgbClr val="B8C4D2"/>
-                </a:solidFill>
-                <a:latin typeface="IBM Plex Mono" pitchFamily="34" charset="0"/>
-                <a:ea typeface="IBM Plex Mono" pitchFamily="34" charset="-122"/>
-                <a:cs typeface="IBM Plex Mono" pitchFamily="34" charset="-120"/>
-              </a:rPr>
-              <a:t>    ON pf1.player_api_id = b.player_api_id</a:t>
-            </a:r>
-            <a:endParaRPr lang="en-US" sz="1388" dirty="0"/>
-          </a:p>
-          <a:p>
-            <a:pPr algn="l" indent="0" marL="0">
-              <a:lnSpc>
-                <a:spcPct val="142000"/>
-              </a:lnSpc>
-              <a:buNone/>
-            </a:pPr>
-            <a:r>
-              <a:rPr lang="en-US" sz="1388" dirty="0">
-                <a:solidFill>
-                  <a:srgbClr val="B8C4D2"/>
-                </a:solidFill>
-                <a:latin typeface="IBM Plex Mono" pitchFamily="34" charset="0"/>
-                <a:ea typeface="IBM Plex Mono" pitchFamily="34" charset="-122"/>
-                <a:cs typeface="IBM Plex Mono" pitchFamily="34" charset="-120"/>
-              </a:rPr>
-              <a:t>  JOIN played_for pf2 ON pf2.t = pf1.t</a:t>
-            </a:r>
-            <a:endParaRPr lang="en-US" sz="1388" dirty="0"/>
-          </a:p>
-          <a:p>
-            <a:pPr algn="l" indent="0" marL="0">
-              <a:lnSpc>
-                <a:spcPct val="142000"/>
-              </a:lnSpc>
-              <a:buNone/>
-            </a:pPr>
-            <a:r>
-              <a:rPr lang="en-US" sz="1388" dirty="0">
-                <a:solidFill>
-                  <a:srgbClr val="B8C4D2"/>
-                </a:solidFill>
-                <a:latin typeface="IBM Plex Mono" pitchFamily="34" charset="0"/>
-                <a:ea typeface="IBM Plex Mono" pitchFamily="34" charset="-122"/>
-                <a:cs typeface="IBM Plex Mono" pitchFamily="34" charset="-120"/>
-              </a:rPr>
-              <a:t>    AND pf2.season = pf1.season</a:t>
-            </a:r>
-            <a:endParaRPr lang="en-US" sz="1388" dirty="0"/>
-          </a:p>
-          <a:p>
-            <a:pPr algn="l" indent="0" marL="0">
-              <a:lnSpc>
-                <a:spcPct val="142000"/>
-              </a:lnSpc>
-              <a:buNone/>
-            </a:pPr>
-            <a:r>
-              <a:rPr lang="en-US" sz="1388" dirty="0">
-                <a:solidFill>
-                  <a:srgbClr val="B8C4D2"/>
-                </a:solidFill>
-                <a:latin typeface="IBM Plex Mono" pitchFamily="34" charset="0"/>
-                <a:ea typeface="IBM Plex Mono" pitchFamily="34" charset="-122"/>
-                <a:cs typeface="IBM Plex Mono" pitchFamily="34" charset="-120"/>
-              </a:rPr>
-              <a:t>    AND pf2.player_api_id &lt;&gt; b.player_api_id</a:t>
-            </a:r>
-            <a:endParaRPr lang="en-US" sz="1388" dirty="0"/>
-          </a:p>
-          <a:p>
-            <a:pPr algn="l" indent="0" marL="0">
-              <a:lnSpc>
-                <a:spcPct val="142000"/>
-              </a:lnSpc>
-              <a:buNone/>
-            </a:pPr>
-            <a:r>
-              <a:rPr lang="en-US" sz="1388" dirty="0">
-                <a:solidFill>
-                  <a:srgbClr val="B8C4D2"/>
-                </a:solidFill>
-                <a:latin typeface="IBM Plex Mono" pitchFamily="34" charset="0"/>
-                <a:ea typeface="IBM Plex Mono" pitchFamily="34" charset="-122"/>
-                <a:cs typeface="IBM Plex Mono" pitchFamily="34" charset="-120"/>
-              </a:rPr>
-              <a:t>  WHERE b.distance &lt; 6</a:t>
-            </a:r>
-            <a:endParaRPr lang="en-US" sz="1388" dirty="0"/>
-          </a:p>
-          <a:p>
-            <a:pPr algn="l" indent="0" marL="0">
-              <a:lnSpc>
-                <a:spcPct val="142000"/>
-              </a:lnSpc>
-              <a:buNone/>
-            </a:pPr>
-            <a:r>
-              <a:rPr lang="en-US" sz="1388" dirty="0">
-                <a:solidFill>
-                  <a:srgbClr val="B8C4D2"/>
-                </a:solidFill>
-                <a:latin typeface="IBM Plex Mono" pitchFamily="34" charset="0"/>
-                <a:ea typeface="IBM Plex Mono" pitchFamily="34" charset="-122"/>
-                <a:cs typeface="IBM Plex Mono" pitchFamily="34" charset="-120"/>
-              </a:rPr>
-              <a:t>)</a:t>
-            </a:r>
-            <a:endParaRPr lang="en-US" sz="1388" dirty="0"/>
-          </a:p>
-          <a:p>
-            <a:pPr algn="l" indent="0" marL="0">
-              <a:lnSpc>
-                <a:spcPct val="142000"/>
-              </a:lnSpc>
-              <a:buNone/>
-            </a:pPr>
-            <a:r>
-              <a:rPr lang="en-US" sz="1388" dirty="0">
-                <a:solidFill>
-                  <a:srgbClr val="B8C4D2"/>
-                </a:solidFill>
-                <a:latin typeface="IBM Plex Mono" pitchFamily="34" charset="0"/>
-                <a:ea typeface="IBM Plex Mono" pitchFamily="34" charset="-122"/>
-                <a:cs typeface="IBM Plex Mono" pitchFamily="34" charset="-120"/>
-              </a:rPr>
-              <a:t>SELECT MIN(distance) FROM bfs ...</a:t>
-            </a:r>
-            <a:endParaRPr lang="en-US" sz="1388" dirty="0"/>
-          </a:p>
-        </p:txBody>
-      </p:sp>
-      <p:sp>
-        <p:nvSpPr>
-          <p:cNvPr id="7" name="Text 5"/>
-          <p:cNvSpPr/>
-          <p:nvPr/>
-        </p:nvSpPr>
-        <p:spPr>
-          <a:xfrm>
-            <a:off x="7677158" y="3763618"/>
-            <a:ext cx="2933644" cy="751098"/>
-          </a:xfrm>
-          <a:prstGeom prst="rect">
-            <a:avLst/>
-          </a:prstGeom>
-          <a:noFill/>
-          <a:ln/>
-        </p:spPr>
-        <p:txBody>
-          <a:bodyPr wrap="square" lIns="25400" tIns="25400" rIns="25400" bIns="25400" rtlCol="0" anchor="t">
-            <a:normAutofit/>
-          </a:bodyPr>
-          <a:lstStyle/>
-          <a:p>
-            <a:pPr algn="ctr" indent="0" marL="0">
-              <a:buNone/>
-            </a:pPr>
-            <a:r>
-              <a:rPr lang="en-US" sz="4350" b="1" dirty="0">
-                <a:solidFill>
-                  <a:srgbClr val="1E7A52"/>
-                </a:solidFill>
-                <a:latin typeface="Space Grotesk" pitchFamily="34" charset="0"/>
-                <a:ea typeface="Space Grotesk" pitchFamily="34" charset="-122"/>
-                <a:cs typeface="Space Grotesk" pitchFamily="34" charset="-120"/>
-              </a:rPr>
-              <a:t>21 → 3</a:t>
-            </a:r>
-            <a:endParaRPr lang="en-US" sz="4350" dirty="0"/>
-          </a:p>
-        </p:txBody>
-      </p:sp>
-      <p:sp>
-        <p:nvSpPr>
-          <p:cNvPr id="8" name="Text 6"/>
-          <p:cNvSpPr/>
-          <p:nvPr/>
-        </p:nvSpPr>
-        <p:spPr>
-          <a:xfrm>
-            <a:off x="7677158" y="4514656"/>
-            <a:ext cx="2933644" cy="298953"/>
-          </a:xfrm>
-          <a:prstGeom prst="rect">
-            <a:avLst/>
-          </a:prstGeom>
-          <a:noFill/>
-          <a:ln/>
-        </p:spPr>
-        <p:txBody>
-          <a:bodyPr wrap="square" lIns="25400" tIns="25400" rIns="25400" bIns="25400" rtlCol="0" anchor="t">
-            <a:normAutofit/>
-          </a:bodyPr>
-          <a:lstStyle/>
-          <a:p>
-            <a:pPr algn="ctr" indent="0" marL="0">
-              <a:buNone/>
-            </a:pPr>
-            <a:r>
-              <a:rPr lang="en-US" sz="1575" dirty="0">
-                <a:solidFill>
-                  <a:srgbClr val="6B655C"/>
-                </a:solidFill>
-                <a:latin typeface="IBM Plex Mono" pitchFamily="34" charset="0"/>
-                <a:ea typeface="IBM Plex Mono" pitchFamily="34" charset="-122"/>
-                <a:cs typeface="IBM Plex Mono" pitchFamily="34" charset="-120"/>
-              </a:rPr>
-              <a:t>lines of code</a:t>
-            </a:r>
-            <a:endParaRPr lang="en-US" sz="1575" dirty="0"/>
-          </a:p>
-        </p:txBody>
-      </p:sp>
-      <p:sp>
-        <p:nvSpPr>
-          <p:cNvPr id="9" name="Text 7"/>
-          <p:cNvSpPr/>
-          <p:nvPr/>
-        </p:nvSpPr>
-        <p:spPr>
-          <a:xfrm>
-            <a:off x="7677158" y="5118286"/>
-            <a:ext cx="2933644" cy="751098"/>
-          </a:xfrm>
-          <a:prstGeom prst="rect">
-            <a:avLst/>
-          </a:prstGeom>
-          <a:noFill/>
-          <a:ln/>
-        </p:spPr>
-        <p:txBody>
-          <a:bodyPr wrap="square" lIns="25400" tIns="25400" rIns="25400" bIns="25400" rtlCol="0" anchor="t">
-            <a:normAutofit/>
-          </a:bodyPr>
-          <a:lstStyle/>
-          <a:p>
-            <a:pPr algn="ctr" indent="0" marL="0">
-              <a:buNone/>
-            </a:pPr>
-            <a:r>
-              <a:rPr lang="en-US" sz="4350" b="1" dirty="0">
-                <a:solidFill>
-                  <a:srgbClr val="1E7A52"/>
-                </a:solidFill>
-                <a:latin typeface="Space Grotesk" pitchFamily="34" charset="0"/>
-                <a:ea typeface="Space Grotesk" pitchFamily="34" charset="-122"/>
-                <a:cs typeface="Space Grotesk" pitchFamily="34" charset="-120"/>
-              </a:rPr>
-              <a:t>26 → 3</a:t>
-            </a:r>
-            <a:endParaRPr lang="en-US" sz="4350" dirty="0"/>
-          </a:p>
-        </p:txBody>
-      </p:sp>
-      <p:sp>
-        <p:nvSpPr>
-          <p:cNvPr id="10" name="Text 8"/>
-          <p:cNvSpPr/>
-          <p:nvPr/>
-        </p:nvSpPr>
-        <p:spPr>
-          <a:xfrm>
-            <a:off x="7677158" y="5869325"/>
-            <a:ext cx="2933644" cy="298953"/>
-          </a:xfrm>
-          <a:prstGeom prst="rect">
-            <a:avLst/>
-          </a:prstGeom>
-          <a:noFill/>
-          <a:ln/>
-        </p:spPr>
-        <p:txBody>
-          <a:bodyPr wrap="square" lIns="25400" tIns="25400" rIns="25400" bIns="25400" rtlCol="0" anchor="t">
-            <a:normAutofit/>
-          </a:bodyPr>
-          <a:lstStyle/>
-          <a:p>
-            <a:pPr algn="ctr" indent="0" marL="0">
-              <a:buNone/>
-            </a:pPr>
-            <a:r>
-              <a:rPr lang="en-US" sz="1575" dirty="0">
-                <a:solidFill>
-                  <a:srgbClr val="6B655C"/>
-                </a:solidFill>
-                <a:latin typeface="IBM Plex Mono" pitchFamily="34" charset="0"/>
-                <a:ea typeface="IBM Plex Mono" pitchFamily="34" charset="-122"/>
-                <a:cs typeface="IBM Plex Mono" pitchFamily="34" charset="-120"/>
-              </a:rPr>
-              <a:t>logical operators</a:t>
-            </a:r>
-            <a:endParaRPr lang="en-US" sz="1575" dirty="0"/>
-          </a:p>
-        </p:txBody>
-      </p:sp>
-      <p:sp>
-        <p:nvSpPr>
-          <p:cNvPr id="11" name="Text 9"/>
-          <p:cNvSpPr/>
-          <p:nvPr/>
-        </p:nvSpPr>
-        <p:spPr>
-          <a:xfrm>
-            <a:off x="7677158" y="6472955"/>
-            <a:ext cx="2933644" cy="751098"/>
-          </a:xfrm>
-          <a:prstGeom prst="rect">
-            <a:avLst/>
-          </a:prstGeom>
-          <a:noFill/>
-          <a:ln/>
-        </p:spPr>
-        <p:txBody>
-          <a:bodyPr wrap="square" lIns="25400" tIns="25400" rIns="25400" bIns="25400" rtlCol="0" anchor="t">
-            <a:normAutofit/>
-          </a:bodyPr>
-          <a:lstStyle/>
-          <a:p>
-            <a:pPr algn="ctr" indent="0" marL="0">
-              <a:buNone/>
-            </a:pPr>
-            <a:r>
-              <a:rPr lang="en-US" sz="4350" b="1" dirty="0">
-                <a:solidFill>
-                  <a:srgbClr val="1E7A52"/>
-                </a:solidFill>
-                <a:latin typeface="Space Grotesk" pitchFamily="34" charset="0"/>
-                <a:ea typeface="Space Grotesk" pitchFamily="34" charset="-122"/>
-                <a:cs typeface="Space Grotesk" pitchFamily="34" charset="-120"/>
-              </a:rPr>
-              <a:t>712 → 8</a:t>
-            </a:r>
-            <a:endParaRPr lang="en-US" sz="4350" dirty="0"/>
-          </a:p>
-        </p:txBody>
-      </p:sp>
-      <p:sp>
-        <p:nvSpPr>
-          <p:cNvPr id="12" name="Text 10"/>
-          <p:cNvSpPr/>
-          <p:nvPr/>
-        </p:nvSpPr>
-        <p:spPr>
-          <a:xfrm>
-            <a:off x="7677158" y="7223994"/>
-            <a:ext cx="2933644" cy="298953"/>
-          </a:xfrm>
-          <a:prstGeom prst="rect">
-            <a:avLst/>
-          </a:prstGeom>
-          <a:noFill/>
-          <a:ln/>
-        </p:spPr>
-        <p:txBody>
-          <a:bodyPr wrap="square" lIns="25400" tIns="25400" rIns="25400" bIns="25400" rtlCol="0" anchor="t">
-            <a:normAutofit/>
-          </a:bodyPr>
-          <a:lstStyle/>
-          <a:p>
-            <a:pPr algn="ctr" indent="0" marL="0">
-              <a:buNone/>
-            </a:pPr>
-            <a:r>
-              <a:rPr lang="en-US" sz="1575" dirty="0">
-                <a:solidFill>
-                  <a:srgbClr val="6B655C"/>
-                </a:solidFill>
-                <a:latin typeface="IBM Plex Mono" pitchFamily="34" charset="0"/>
-                <a:ea typeface="IBM Plex Mono" pitchFamily="34" charset="-122"/>
-                <a:cs typeface="IBM Plex Mono" pitchFamily="34" charset="-120"/>
-              </a:rPr>
-              <a:t>milliseconds</a:t>
-            </a:r>
-            <a:endParaRPr lang="en-US" sz="1575" dirty="0"/>
-          </a:p>
-        </p:txBody>
-      </p:sp>
-      <p:sp>
-        <p:nvSpPr>
-          <p:cNvPr id="13" name="Shape 11"/>
-          <p:cNvSpPr/>
-          <p:nvPr/>
-        </p:nvSpPr>
-        <p:spPr>
-          <a:xfrm>
-            <a:off x="10858408" y="2208011"/>
-            <a:ext cx="6477167" cy="6832443"/>
-          </a:xfrm>
-          <a:prstGeom prst="rect">
-            <a:avLst/>
-          </a:prstGeom>
-          <a:solidFill>
-            <a:srgbClr val="16202C"/>
-          </a:solidFill>
-          <a:ln/>
-        </p:spPr>
-      </p:sp>
-      <p:sp>
-        <p:nvSpPr>
-          <p:cNvPr id="14" name="Text 12"/>
-          <p:cNvSpPr/>
-          <p:nvPr/>
-        </p:nvSpPr>
-        <p:spPr>
-          <a:xfrm>
-            <a:off x="11239362" y="2531767"/>
-            <a:ext cx="6286785" cy="298953"/>
-          </a:xfrm>
-          <a:prstGeom prst="rect">
-            <a:avLst/>
-          </a:prstGeom>
-          <a:noFill/>
-          <a:ln/>
-        </p:spPr>
-        <p:txBody>
-          <a:bodyPr wrap="square" lIns="25400" tIns="25400" rIns="25400" bIns="25400" rtlCol="0" anchor="t">
-            <a:normAutofit/>
-          </a:bodyPr>
-          <a:lstStyle/>
-          <a:p>
-            <a:pPr algn="l" indent="0" marL="0">
-              <a:buNone/>
-            </a:pPr>
-            <a:r>
-              <a:rPr lang="en-US" sz="1575" spc="158" kern="0" dirty="0">
-                <a:solidFill>
-                  <a:srgbClr val="6FC79B"/>
-                </a:solidFill>
-                <a:latin typeface="IBM Plex Mono" pitchFamily="34" charset="0"/>
-                <a:ea typeface="IBM Plex Mono" pitchFamily="34" charset="-122"/>
-                <a:cs typeface="IBM Plex Mono" pitchFamily="34" charset="-120"/>
-              </a:rPr>
-              <a:t>NEO4J — BUILT-IN SHORTESTPATH()</a:t>
-            </a:r>
-            <a:endParaRPr lang="en-US" sz="1575" dirty="0"/>
-          </a:p>
-        </p:txBody>
-      </p:sp>
-      <p:sp>
-        <p:nvSpPr>
-          <p:cNvPr id="15" name="Text 13"/>
-          <p:cNvSpPr/>
-          <p:nvPr/>
-        </p:nvSpPr>
-        <p:spPr>
-          <a:xfrm>
-            <a:off x="11239362" y="4926179"/>
-            <a:ext cx="4944243" cy="1866244"/>
-          </a:xfrm>
-          <a:prstGeom prst="rect">
-            <a:avLst/>
-          </a:prstGeom>
-          <a:noFill/>
-          <a:ln/>
-        </p:spPr>
-        <p:txBody>
-          <a:bodyPr wrap="none" lIns="25400" tIns="25400" rIns="25400" bIns="25400" rtlCol="0" anchor="t">
-            <a:normAutofit/>
-          </a:bodyPr>
-          <a:lstStyle/>
-          <a:p>
-            <a:pPr algn="l" indent="0" marL="0">
-              <a:lnSpc>
-                <a:spcPct val="160000"/>
-              </a:lnSpc>
-              <a:buNone/>
-            </a:pPr>
-            <a:r>
-              <a:rPr lang="en-US" sz="2250" dirty="0">
+              <a:t>MATCH (a:Player {name: $player_a}),</a:t>
+            </a:r>
+            <a:endParaRPr lang="en-US" sz="2250" dirty="0"/>
+          </a:p>
+          <a:p>
+            <a:r>
+              <a:rPr sz="2250">
                 <a:solidFill>
                   <a:srgbClr val="D5E5DC"/>
                 </a:solidFill>
-                <a:latin typeface="IBM Plex Mono" pitchFamily="34" charset="0"/>
-                <a:ea typeface="IBM Plex Mono" pitchFamily="34" charset="-122"/>
-                <a:cs typeface="IBM Plex Mono" pitchFamily="34" charset="-120"/>
-              </a:rPr>
-              <a:t>MATCH path = shortestPath(</a:t>
-            </a:r>
-            <a:endParaRPr lang="en-US" sz="2250" dirty="0"/>
-          </a:p>
-          <a:p>
-            <a:pPr algn="l" indent="0" marL="0">
-              <a:lnSpc>
-                <a:spcPct val="160000"/>
-              </a:lnSpc>
-              <a:buNone/>
-            </a:pPr>
-            <a:r>
-              <a:rPr lang="en-US" sz="2250" dirty="0">
+                <a:latin typeface="IBM Plex Mono"/>
+              </a:rPr>
+              <a:t>      (b:Player {name: $player_b})</a:t>
+            </a:r>
+          </a:p>
+          <a:p>
+            <a:r>
+              <a:rPr sz="2250">
                 <a:solidFill>
                   <a:srgbClr val="D5E5DC"/>
                 </a:solidFill>
-                <a:latin typeface="IBM Plex Mono" pitchFamily="34" charset="0"/>
-                <a:ea typeface="IBM Plex Mono" pitchFamily="34" charset="-122"/>
-                <a:cs typeface="IBM Plex Mono" pitchFamily="34" charset="-120"/>
-              </a:rPr>
-              <a:t>  (a)-[:PLAYED_FOR*..12]-(b)</a:t>
-            </a:r>
-            <a:endParaRPr lang="en-US" sz="2250" dirty="0"/>
-          </a:p>
-          <a:p>
-            <a:pPr algn="l" indent="0" marL="0">
-              <a:lnSpc>
-                <a:spcPct val="160000"/>
-              </a:lnSpc>
-              <a:buNone/>
-            </a:pPr>
-            <a:r>
-              <a:rPr lang="en-US" sz="2250" dirty="0">
+                <a:latin typeface="IBM Plex Mono"/>
+              </a:rPr>
+              <a:t>MATCH path = SHORTEST 1 (a)</a:t>
+            </a:r>
+          </a:p>
+          <a:p>
+            <a:r>
+              <a:rPr sz="2250">
                 <a:solidFill>
                   <a:srgbClr val="D5E5DC"/>
                 </a:solidFill>
-                <a:latin typeface="IBM Plex Mono" pitchFamily="34" charset="0"/>
-                <a:ea typeface="IBM Plex Mono" pitchFamily="34" charset="-122"/>
-                <a:cs typeface="IBM Plex Mono" pitchFamily="34" charset="-120"/>
-              </a:rPr>
-              <a:t>)</a:t>
-            </a:r>
-            <a:endParaRPr lang="en-US" sz="2250" dirty="0"/>
-          </a:p>
-          <a:p>
-            <a:pPr algn="l" indent="0" marL="0">
-              <a:lnSpc>
-                <a:spcPct val="160000"/>
-              </a:lnSpc>
-              <a:buNone/>
-            </a:pPr>
-            <a:r>
-              <a:rPr lang="en-US" sz="2250" dirty="0">
+                <a:latin typeface="IBM Plex Mono"/>
+              </a:rPr>
+              <a:t>  ((x:Player)-[r1:PLAYED_FOR]-&gt;(:Team)</a:t>
+            </a:r>
+          </a:p>
+          <a:p>
+            <a:r>
+              <a:rPr sz="2250">
                 <a:solidFill>
                   <a:srgbClr val="D5E5DC"/>
                 </a:solidFill>
-                <a:latin typeface="IBM Plex Mono" pitchFamily="34" charset="0"/>
-                <a:ea typeface="IBM Plex Mono" pitchFamily="34" charset="-122"/>
-                <a:cs typeface="IBM Plex Mono" pitchFamily="34" charset="-120"/>
+                <a:latin typeface="IBM Plex Mono"/>
+              </a:rPr>
+              <a:t>    &lt;-[r2:PLAYED_FOR]-(y:Player)</a:t>
+            </a:r>
+          </a:p>
+          <a:p>
+            <a:r>
+              <a:rPr sz="2250">
+                <a:solidFill>
+                  <a:srgbClr val="D5E5DC"/>
+                </a:solidFill>
+                <a:latin typeface="IBM Plex Mono"/>
+              </a:rPr>
+              <a:t>    WHERE r1.season = r2.season){1,6}</a:t>
+            </a:r>
+          </a:p>
+          <a:p>
+            <a:r>
+              <a:rPr sz="2250">
+                <a:solidFill>
+                  <a:srgbClr val="D5E5DC"/>
+                </a:solidFill>
+                <a:latin typeface="IBM Plex Mono"/>
+              </a:rPr>
+              <a:t>  (b)</a:t>
+            </a:r>
+          </a:p>
+          <a:p>
+            <a:r>
+              <a:rPr sz="2250">
+                <a:solidFill>
+                  <a:srgbClr val="D5E5DC"/>
+                </a:solidFill>
+                <a:latin typeface="IBM Plex Mono"/>
               </a:rPr>
               <a:t>RETURN length(path) / 2;</a:t>
             </a:r>
-            <a:endParaRPr lang="en-US" sz="2250" dirty="0"/>
           </a:p>
         </p:txBody>
       </p:sp>
@@ -6916,7 +6641,7 @@
                 <a:ea typeface="Space Grotesk" pitchFamily="34" charset="-122"/>
                 <a:cs typeface="Space Grotesk" pitchFamily="34" charset="-120"/>
               </a:rPr>
-              <a:t>Cypher is not just faster: it's 7× shorter — and a schema change is one SET, not a migration</a:t>
+              <a:t>Cypher is not just faster: it's 4× shorter — and a schema change is one SET, not a migration</a:t>
             </a:r>
             <a:endParaRPr lang="en-US" sz="4350" dirty="0"/>
           </a:p>
@@ -7026,7 +6751,7 @@
                 <a:ea typeface="Space Grotesk" pitchFamily="34" charset="-122"/>
                 <a:cs typeface="Space Grotesk" pitchFamily="34" charset="-120"/>
               </a:rPr>
-              <a:t>7×</a:t>
+              <a:t>4×</a:t>
             </a:r>
             <a:endParaRPr lang="en-US" sz="7200" dirty="0"/>
           </a:p>
@@ -7081,7 +6806,7 @@
                 <a:ea typeface="IBM Plex Mono" pitchFamily="34" charset="-122"/>
                 <a:cs typeface="IBM Plex Mono" pitchFamily="34" charset="-120"/>
               </a:rPr>
-              <a:t>21 SQL → 3 Cypher</a:t>
+              <a:t>21 SQL → 5 Cypher</a:t>
             </a:r>
             <a:endParaRPr lang="en-US" sz="2100" dirty="0"/>
           </a:p>
@@ -7125,7 +6850,7 @@
                 <a:ea typeface="Space Grotesk" pitchFamily="34" charset="-122"/>
                 <a:cs typeface="Space Grotesk" pitchFamily="34" charset="-120"/>
               </a:rPr>
-              <a:t>8.7×</a:t>
+              <a:t>5×</a:t>
             </a:r>
             <a:endParaRPr lang="en-US" sz="7200" dirty="0"/>
           </a:p>
@@ -7180,7 +6905,7 @@
                 <a:ea typeface="IBM Plex Mono" pitchFamily="34" charset="-122"/>
                 <a:cs typeface="IBM Plex Mono" pitchFamily="34" charset="-120"/>
               </a:rPr>
-              <a:t>26 SQL → 3 Cypher</a:t>
+              <a:t>26 SQL → 5 Cypher</a:t>
             </a:r>
             <a:endParaRPr lang="en-US" sz="2100" dirty="0"/>
           </a:p>
@@ -7693,7 +7418,7 @@
                 <a:ea typeface="Space Grotesk" pitchFamily="34" charset="-122"/>
                 <a:cs typeface="Space Grotesk" pitchFamily="34" charset="-120"/>
               </a:rPr>
-              <a:t>443 ms vs 32 ms (13.7×) </a:t>
+              <a:t>352 ms vs 78 ms (4.5×, measured through COMMIT) </a:t>
             </a:r>
             <a:pPr algn="l" indent="0" marL="0">
               <a:lnSpc>
@@ -8022,7 +7747,7 @@
                 <a:ea typeface="Space Grotesk" pitchFamily="34" charset="-122"/>
                 <a:cs typeface="Space Grotesk" pitchFamily="34" charset="-120"/>
               </a:rPr>
-              <a:t>Postgres still wins where it has always won</a:t>
+              <a:t>Where the depth is fixed, the relational join still wins</a:t>
             </a:r>
             <a:endParaRPr lang="en-US" sz="2325" dirty="0"/>
           </a:p>
@@ -8066,7 +7791,7 @@
                 <a:ea typeface="Space Grotesk" pitchFamily="34" charset="-122"/>
                 <a:cs typeface="Space Grotesk" pitchFamily="34" charset="-120"/>
               </a:rPr>
-              <a:t>Aggregations and small-fan-out joins (Q02, Q03): 30 years of planner optimisation no graph engine matches.</a:t>
+              <a:t>Two-hop teammates (Q09): with the same precomputed relation, B-tree joins beat the traversal 2.1× — and the gap widens with data. Light aggregations (&lt; 15 ms) are a dead heat: the winner flips between runs.</a:t>
             </a:r>
             <a:endParaRPr lang="en-US" sz="1800" dirty="0"/>
           </a:p>
@@ -8179,7 +7904,7 @@
                 <a:ea typeface="Space Grotesk" pitchFamily="34" charset="-122"/>
                 <a:cs typeface="Space Grotesk" pitchFamily="34" charset="-120"/>
               </a:rPr>
-              <a:t>Neo4j wins graph workloads by an order of magnitude</a:t>
+              <a:t>Neo4j wins where the depth is variable — by a class</a:t>
             </a:r>
             <a:endParaRPr lang="en-US" sz="2325" dirty="0"/>
           </a:p>
@@ -8223,7 +7948,7 @@
                 <a:ea typeface="Space Grotesk" pitchFamily="34" charset="-122"/>
                 <a:cs typeface="Space Grotesk" pitchFamily="34" charset="-120"/>
               </a:rPr>
-              <a:t>Q07 6.2×, Q10 89× — and the Cypher code is dramatically more concise on exactly those queries.</a:t>
+              <a:t>Q10 57× with identical semantics: the recursive CTE explores 44,251 states, SHORTEST 1 touches 4,402 db hits. Q07 (1.9×) and Q06 (3.6×) follow, and Neo4j's edge on Q07 grows with the data.</a:t>
             </a:r>
             <a:endParaRPr lang="en-US" sz="1800" dirty="0"/>
           </a:p>
@@ -8380,7 +8105,7 @@
                 <a:ea typeface="Space Grotesk" pitchFamily="34" charset="-122"/>
                 <a:cs typeface="Space Grotesk" pitchFamily="34" charset="-120"/>
               </a:rPr>
-              <a:t>One SET vs ALTER + UPDATE. In change-heavy environments this matters more than raw milliseconds.</a:t>
+              <a:t>One SET vs ALTER + UPDATE: 4.5× measured through commit. In change-heavy environments this matters more than raw milliseconds.</a:t>
             </a:r>
             <a:endParaRPr lang="en-US" sz="1800" dirty="0"/>
           </a:p>
@@ -8482,7 +8207,7 @@
                 <a:ea typeface="Space Grotesk" pitchFamily="34" charset="-122"/>
                 <a:cs typeface="Space Grotesk" pitchFamily="34" charset="-120"/>
               </a:rPr>
-              <a:t>Single node, single user, default configs, medium scale — full limitations &amp; future work in backup.</a:t>
+              <a:t>Single node, single user, default configs. Four sensitivity analyses in the report: work_mem (no effect), Q10 semantics (fixed), MVCC bloat (VACUUM protocol), scaling on 2/4/8 seasons (measured).</a:t>
             </a:r>
             <a:endParaRPr lang="en-US" sz="1875" dirty="0"/>
           </a:p>
@@ -9440,7 +9165,7 @@
                 <a:ea typeface="IBM Plex Mono" pitchFamily="34" charset="-122"/>
                 <a:cs typeface="IBM Plex Mono" pitchFamily="34" charset="-120"/>
               </a:rPr>
-              <a:t>github.com/g1up3 · github.com/theunick reports/benchmark_report.md</a:t>
+              <a:t>github.com/g1up3/DM-Project-2026 · reports/benchmark_report.md</a:t>
             </a:r>
             <a:endParaRPr lang="en-US" sz="1650" dirty="0"/>
           </a:p>
@@ -11682,7 +11407,7 @@
                 <a:ea typeface="Space Grotesk" pitchFamily="34" charset="-122"/>
                 <a:cs typeface="Space Grotesk" pitchFamily="34" charset="-120"/>
               </a:rPr>
-              <a:t>917k events. LDBC-SNB-style graphs at 10× would stress the traversal advantage further.</a:t>
+              <a:t>Measured on 2/4/8 seasons: Neo4j's aggregation edge widens with data, Postgres' fixed-depth join edge too. LDBC-SNB scale is future work.</a:t>
             </a:r>
             <a:endParaRPr lang="en-US" sz="1800" dirty="0"/>
           </a:p>
@@ -12035,7 +11760,7 @@
                 <a:ea typeface="Space Grotesk" pitchFamily="34" charset="-122"/>
                 <a:cs typeface="Space Grotesk" pitchFamily="34" charset="-120"/>
               </a:rPr>
-              <a:t>No absolute winner: Neo4j dominates traversals — up to 89× — while Postgres wins every aggregation</a:t>
+              <a:t>No absolute winner: Neo4j dominates variable-depth traversals — 57× on shortest path — while light aggregations are a dead heat and Postgres keeps the fixed-depth join</a:t>
             </a:r>
             <a:endParaRPr lang="en-US" sz="4650" dirty="0"/>
           </a:p>
@@ -12104,7 +11829,7 @@
                 <a:ea typeface="Space Grotesk" pitchFamily="34" charset="-122"/>
                 <a:cs typeface="Space Grotesk" pitchFamily="34" charset="-120"/>
               </a:rPr>
-              <a:t>89×</a:t>
+              <a:t>57×</a:t>
             </a:r>
             <a:endParaRPr lang="en-US" sz="9750" dirty="0"/>
           </a:p>
@@ -12189,7 +11914,7 @@
                 <a:ea typeface="Space Grotesk" pitchFamily="34" charset="-122"/>
                 <a:cs typeface="Space Grotesk" pitchFamily="34" charset="-120"/>
               </a:rPr>
-              <a:t>Q10: 712 ms in Postgres, 8 ms in Neo4j — a change of complexity class, not a tuning win.</a:t>
+              <a:t>Q10: 671 ms in Postgres, 12 ms in Neo4j — identical semantics, a change of complexity class.</a:t>
             </a:r>
             <a:endParaRPr lang="en-US" sz="1800" dirty="0"/>
           </a:p>
@@ -12258,7 +11983,7 @@
                 <a:ea typeface="Space Grotesk" pitchFamily="34" charset="-122"/>
                 <a:cs typeface="Space Grotesk" pitchFamily="34" charset="-120"/>
               </a:rPr>
-              <a:t>4/4</a:t>
+              <a:t>2.1×</a:t>
             </a:r>
             <a:endParaRPr lang="en-US" sz="9750" dirty="0"/>
           </a:p>
@@ -12299,7 +12024,7 @@
                 <a:ea typeface="Space Grotesk" pitchFamily="34" charset="-122"/>
                 <a:cs typeface="Space Grotesk" pitchFamily="34" charset="-120"/>
               </a:rPr>
-              <a:t>relational queries won by Postgres</a:t>
+              <a:t>Postgres on the fixed-depth join (Q09)</a:t>
             </a:r>
             <a:endParaRPr lang="en-US" sz="2250" dirty="0"/>
           </a:p>
@@ -12343,7 +12068,7 @@
                 <a:ea typeface="Space Grotesk" pitchFamily="34" charset="-122"/>
                 <a:cs typeface="Space Grotesk" pitchFamily="34" charset="-120"/>
               </a:rPr>
-              <a:t>Aggregations and small joins: 30 years of planner optimisation still pay off.</a:t>
+              <a:t>With the same precomputation, B-tree joins beat the traversal — and the lead widens as data grows. The four light aggregations (&lt; 15 ms) are a dead heat.</a:t>
             </a:r>
             <a:endParaRPr lang="en-US" sz="1800" dirty="0"/>
           </a:p>
@@ -12412,7 +12137,7 @@
                 <a:ea typeface="Space Grotesk" pitchFamily="34" charset="-122"/>
                 <a:cs typeface="Space Grotesk" pitchFamily="34" charset="-120"/>
               </a:rPr>
-              <a:t>7×</a:t>
+              <a:t>4×</a:t>
             </a:r>
             <a:endParaRPr lang="en-US" sz="9750" dirty="0"/>
           </a:p>
@@ -12497,7 +12222,7 @@
                 <a:ea typeface="Space Grotesk" pitchFamily="34" charset="-122"/>
                 <a:cs typeface="Space Grotesk" pitchFamily="34" charset="-120"/>
               </a:rPr>
-              <a:t>21 SQL lines become 3 Cypher lines on graph queries — expressiveness is a result too.</a:t>
+              <a:t>21 SQL lines become 5 Cypher lines on graph queries — expressiveness is a result too.</a:t>
             </a:r>
             <a:endParaRPr lang="en-US" sz="1800" dirty="0"/>
           </a:p>
@@ -17934,7 +17659,7 @@
                 <a:ea typeface="IBM Plex Mono" pitchFamily="34" charset="-122"/>
                 <a:cs typeface="IBM Plex Mono" pitchFamily="34" charset="-120"/>
               </a:rPr>
-              <a:t>PostgreSQL 18.3 </a:t>
+              <a:t>PostgreSQL 18.6 </a:t>
             </a:r>
             <a:pPr algn="l" indent="0" marL="0">
               <a:lnSpc>
@@ -18540,7 +18265,7 @@
                 <a:ea typeface="Space Grotesk" pitchFamily="34" charset="-122"/>
                 <a:cs typeface="Space Grotesk" pitchFamily="34" charset="-120"/>
               </a:rPr>
-              <a:t>Both result-sets normalised (rounding, dates, decimals) and compared as sets. </a:t>
+              <a:t>Both result-sets normalised (rounding, dates, decimals) and compared as multisets. </a:t>
             </a:r>
             <a:pPr algn="l" indent="0" marL="0">
               <a:lnSpc>
@@ -18844,7 +18569,7 @@
                 <a:ea typeface="Space Grotesk" pitchFamily="34" charset="-122"/>
                 <a:cs typeface="Space Grotesk" pitchFamily="34" charset="-120"/>
               </a:rPr>
-              <a:t>on Q08–Q10.</a:t>
+              <a:t>on Q09–Q10.</a:t>
             </a:r>
             <a:endParaRPr lang="en-US" sz="1950" dirty="0"/>
           </a:p>

</xml_diff>

<commit_message>
Holm correction in the harness (significant_holm column) + Q10 semantics note on slide 12
- run_benchmark.holm_correction(): step-down over the family of 12 tests,
  written to significance.csv; generate_report.py reads the column (or
  recomputes it with the same function for older runs); unit test added
- The two runs of 2026-09-21 get the column post hoc (deterministic from
  their p-values)
- Slide 12 footnote: legacy shortestPath() diverges from the SQL BFS on
  1 of 8 pairs; replaced by the quantified path pattern (report 10.2)

Co-Authored-By: Claude Opus 5 <noreply@anthropic.com>
</commit_message>
<xml_diff>
--- a/PostgreSQL_vs_Neo4j_DAngelica_Leone.pptx
+++ b/PostgreSQL_vs_Neo4j_DAngelica_Leone.pptx
@@ -784,7 +784,7 @@
           <a:lstStyle/>
           <a:p>
             <a:r>
-              <a:t>60 sec. La sproporzione visiva È il messaggio: stessa domanda, 21 righe contro 5. Non leggere il codice: indicare solo la CTE ricorsiva a sinistra e SHORTEST 1 a destra.</a:t>
+              <a:t>60 sec. La sproporzione visiva È il messaggio: stessa domanda, 21 righe contro 5. Non leggere il codice: indicare solo la CTE ricorsiva a sinistra e SHORTEST 1 a destra. If asked how we know the semantics match: we ran both formulations on 8 player pairs; the legacy shortestPath() answered 2 hops on Ibrahimovic-Neuer where the season-aware BFS says 3, so we replaced it. That is how we know the 55x is real and not an artefact of a laxer query.</a:t>
             </a:r>
           </a:p>
         </p:txBody>
@@ -3962,7 +3962,7 @@
         <p:spPr>
           <a:xfrm>
             <a:off x="952385" y="2208011"/>
-            <a:ext cx="6477167" cy="6832443"/>
+            <a:ext cx="6477167" cy="6295909"/>
           </a:xfrm>
           <a:prstGeom prst="rect">
             <a:avLst/>
@@ -4027,7 +4027,7 @@
         <p:spPr>
           <a:xfrm>
             <a:off x="1333339" y="2963941"/>
-            <a:ext cx="5886716" cy="5790856"/>
+            <a:ext cx="5886716" cy="5539979"/>
           </a:xfrm>
           <a:prstGeom prst="rect">
             <a:avLst/>
@@ -4471,7 +4471,7 @@
         <p:spPr>
           <a:xfrm>
             <a:off x="10858408" y="2208011"/>
-            <a:ext cx="6477167" cy="6832443"/>
+            <a:ext cx="6477167" cy="6295909"/>
           </a:xfrm>
           <a:prstGeom prst="rect">
             <a:avLst/>
@@ -4727,6 +4727,47 @@
               <a:t>12 / 16</a:t>
             </a:r>
             <a:endParaRPr lang="en-US" sz="1425" dirty="0"/>
+          </a:p>
+        </p:txBody>
+      </p:sp>
+      <p:sp>
+        <p:nvSpPr>
+          <p:cNvPr id="3001" name="Text 69"/>
+          <p:cNvSpPr/>
+          <p:nvPr/>
+        </p:nvSpPr>
+        <p:spPr>
+          <a:xfrm>
+            <a:off x="950976" y="8686800"/>
+            <a:ext cx="16386048" cy="548640"/>
+          </a:xfrm>
+          <a:prstGeom prst="rect">
+            <a:avLst/>
+          </a:prstGeom>
+          <a:noFill/>
+          <a:ln/>
+        </p:spPr>
+        <p:txBody>
+          <a:bodyPr wrap="square" lIns="25400" tIns="25400" rIns="25400" bIns="25400" rtlCol="0" anchor="t">
+            <a:normAutofit/>
+          </a:bodyPr>
+          <a:lstStyle/>
+          <a:p>
+            <a:pPr algn="l" indent="0" marL="0">
+              <a:buNone/>
+            </a:pPr>
+            <a:r>
+              <a:rPr lang="en-US" sz="1450" dirty="0">
+                <a:solidFill>
+                  <a:srgbClr val="6B655C"/>
+                </a:solidFill>
+                <a:latin typeface="Space Grotesk" pitchFamily="34" charset="0"/>
+                <a:ea typeface="IBM Plex Mono" pitchFamily="34" charset="-122"/>
+                <a:cs typeface="IBM Plex Mono" pitchFamily="34" charset="-120"/>
+              </a:rPr>
+              <a:t>Semantics verified, not assumed: the legacy shortestPath() diverges from the SQL BFS on 1 of 8 player pairs (Ibrahimović → Neuer: 2 hops instead of 3) because it ignores the season between consecutive edges — replaced by the quantified path pattern (report §10.2).</a:t>
+            </a:r>
+            <a:endParaRPr lang="en-US" sz="1575" dirty="0"/>
           </a:p>
         </p:txBody>
       </p:sp>

</xml_diff>